<commit_message>
add chi-square excel in slides
</commit_message>
<xml_diff>
--- a/Part 2 - Inferential Statisitcs/Part 2.3 - Introduction to Hypothesis Testing/Part 2.3 - Introduction to Hypthesis Testing.pptx
+++ b/Part 2 - Inferential Statisitcs/Part 2.3 - Introduction to Hypothesis Testing/Part 2.3 - Introduction to Hypthesis Testing.pptx
@@ -5,7 +5,7 @@
     <p:sldMasterId id="2147483648" r:id="rId1"/>
   </p:sldMasterIdLst>
   <p:notesMasterIdLst>
-    <p:notesMasterId r:id="rId55"/>
+    <p:notesMasterId r:id="rId56"/>
   </p:notesMasterIdLst>
   <p:sldIdLst>
     <p:sldId id="483" r:id="rId2"/>
@@ -53,14 +53,15 @@
     <p:sldId id="689" r:id="rId44"/>
     <p:sldId id="765" r:id="rId45"/>
     <p:sldId id="692" r:id="rId46"/>
-    <p:sldId id="658" r:id="rId47"/>
-    <p:sldId id="661" r:id="rId48"/>
-    <p:sldId id="672" r:id="rId49"/>
-    <p:sldId id="675" r:id="rId50"/>
-    <p:sldId id="674" r:id="rId51"/>
-    <p:sldId id="728" r:id="rId52"/>
-    <p:sldId id="726" r:id="rId53"/>
-    <p:sldId id="695" r:id="rId54"/>
+    <p:sldId id="766" r:id="rId47"/>
+    <p:sldId id="658" r:id="rId48"/>
+    <p:sldId id="661" r:id="rId49"/>
+    <p:sldId id="672" r:id="rId50"/>
+    <p:sldId id="675" r:id="rId51"/>
+    <p:sldId id="674" r:id="rId52"/>
+    <p:sldId id="728" r:id="rId53"/>
+    <p:sldId id="726" r:id="rId54"/>
+    <p:sldId id="695" r:id="rId55"/>
   </p:sldIdLst>
   <p:sldSz cx="12192000" cy="6858000"/>
   <p:notesSz cx="6858000" cy="9144000"/>
@@ -534,7 +535,7 @@
   <pc:docChgLst>
     <pc:chgData name="Mohammed Fasha" userId="cc64f42d-a1a6-4f08-b97b-0c37f877119f" providerId="ADAL" clId="{5F852C96-121E-4103-85D0-117B736085A1}"/>
     <pc:docChg chg="undo custSel addSld delSld modSld sldOrd">
-      <pc:chgData name="Mohammed Fasha" userId="cc64f42d-a1a6-4f08-b97b-0c37f877119f" providerId="ADAL" clId="{5F852C96-121E-4103-85D0-117B736085A1}" dt="2025-05-28T03:46:24.708" v="4225" actId="122"/>
+      <pc:chgData name="Mohammed Fasha" userId="cc64f42d-a1a6-4f08-b97b-0c37f877119f" providerId="ADAL" clId="{5F852C96-121E-4103-85D0-117B736085A1}" dt="2025-06-03T05:07:41.628" v="4263" actId="20577"/>
       <pc:docMkLst>
         <pc:docMk/>
       </pc:docMkLst>
@@ -1329,22 +1330,6 @@
           <pc:docMk/>
           <pc:sldMk cId="632086538" sldId="682"/>
         </pc:sldMkLst>
-        <pc:spChg chg="mod">
-          <ac:chgData name="Mohammed Fasha" userId="cc64f42d-a1a6-4f08-b97b-0c37f877119f" providerId="ADAL" clId="{5F852C96-121E-4103-85D0-117B736085A1}" dt="2025-05-28T03:02:00.323" v="3384" actId="21"/>
-          <ac:spMkLst>
-            <pc:docMk/>
-            <pc:sldMk cId="632086538" sldId="682"/>
-            <ac:spMk id="3" creationId="{82330144-6753-370A-BDCC-FBBBCB8FC516}"/>
-          </ac:spMkLst>
-        </pc:spChg>
-        <pc:picChg chg="add mod">
-          <ac:chgData name="Mohammed Fasha" userId="cc64f42d-a1a6-4f08-b97b-0c37f877119f" providerId="ADAL" clId="{5F852C96-121E-4103-85D0-117B736085A1}" dt="2025-05-28T03:01:55.492" v="3383"/>
-          <ac:picMkLst>
-            <pc:docMk/>
-            <pc:sldMk cId="632086538" sldId="682"/>
-            <ac:picMk id="4" creationId="{C0785276-DEC3-77E8-D8C5-B5DF6C2A4CE5}"/>
-          </ac:picMkLst>
-        </pc:picChg>
       </pc:sldChg>
       <pc:sldChg chg="del modTransition">
         <pc:chgData name="Mohammed Fasha" userId="cc64f42d-a1a6-4f08-b97b-0c37f877119f" providerId="ADAL" clId="{5F852C96-121E-4103-85D0-117B736085A1}" dt="2025-05-28T02:57:35.487" v="3376" actId="2696"/>
@@ -1366,38 +1351,6 @@
           <pc:docMk/>
           <pc:sldMk cId="2847060586" sldId="683"/>
         </pc:sldMkLst>
-        <pc:spChg chg="add mod">
-          <ac:chgData name="Mohammed Fasha" userId="cc64f42d-a1a6-4f08-b97b-0c37f877119f" providerId="ADAL" clId="{5F852C96-121E-4103-85D0-117B736085A1}" dt="2025-05-28T03:23:42.612" v="3838" actId="21"/>
-          <ac:spMkLst>
-            <pc:docMk/>
-            <pc:sldMk cId="2847060586" sldId="683"/>
-            <ac:spMk id="4" creationId="{0F0F8B44-4AFA-695E-C9EE-35313D604F3C}"/>
-          </ac:spMkLst>
-        </pc:spChg>
-        <pc:picChg chg="add del mod">
-          <ac:chgData name="Mohammed Fasha" userId="cc64f42d-a1a6-4f08-b97b-0c37f877119f" providerId="ADAL" clId="{5F852C96-121E-4103-85D0-117B736085A1}" dt="2025-05-28T03:20:45.773" v="3586" actId="21"/>
-          <ac:picMkLst>
-            <pc:docMk/>
-            <pc:sldMk cId="2847060586" sldId="683"/>
-            <ac:picMk id="5" creationId="{7FDD7C87-6909-64CA-A587-61A30C42F2BE}"/>
-          </ac:picMkLst>
-        </pc:picChg>
-        <pc:picChg chg="del mod">
-          <ac:chgData name="Mohammed Fasha" userId="cc64f42d-a1a6-4f08-b97b-0c37f877119f" providerId="ADAL" clId="{5F852C96-121E-4103-85D0-117B736085A1}" dt="2025-05-28T03:23:42.612" v="3838" actId="21"/>
-          <ac:picMkLst>
-            <pc:docMk/>
-            <pc:sldMk cId="2847060586" sldId="683"/>
-            <ac:picMk id="6" creationId="{1FD29ADE-F46E-E9EA-DA8F-199E7FED1006}"/>
-          </ac:picMkLst>
-        </pc:picChg>
-        <pc:picChg chg="add del mod">
-          <ac:chgData name="Mohammed Fasha" userId="cc64f42d-a1a6-4f08-b97b-0c37f877119f" providerId="ADAL" clId="{5F852C96-121E-4103-85D0-117B736085A1}" dt="2025-05-28T03:20:29.559" v="3581" actId="21"/>
-          <ac:picMkLst>
-            <pc:docMk/>
-            <pc:sldMk cId="2847060586" sldId="683"/>
-            <ac:picMk id="1026" creationId="{4777CF26-0F99-41D1-84BC-BEB619F5AAA3}"/>
-          </ac:picMkLst>
-        </pc:picChg>
       </pc:sldChg>
       <pc:sldChg chg="addSp delSp modSp add del mod">
         <pc:chgData name="Mohammed Fasha" userId="cc64f42d-a1a6-4f08-b97b-0c37f877119f" providerId="ADAL" clId="{5F852C96-121E-4103-85D0-117B736085A1}" dt="2025-05-28T03:19:56.267" v="3575" actId="47"/>
@@ -1405,22 +1358,6 @@
           <pc:docMk/>
           <pc:sldMk cId="2358797417" sldId="684"/>
         </pc:sldMkLst>
-        <pc:spChg chg="add mod">
-          <ac:chgData name="Mohammed Fasha" userId="cc64f42d-a1a6-4f08-b97b-0c37f877119f" providerId="ADAL" clId="{5F852C96-121E-4103-85D0-117B736085A1}" dt="2025-05-28T03:19:39.388" v="3571" actId="21"/>
-          <ac:spMkLst>
-            <pc:docMk/>
-            <pc:sldMk cId="2358797417" sldId="684"/>
-            <ac:spMk id="4" creationId="{384E914B-704B-BF44-56B2-477A0323D9BD}"/>
-          </ac:spMkLst>
-        </pc:spChg>
-        <pc:picChg chg="del">
-          <ac:chgData name="Mohammed Fasha" userId="cc64f42d-a1a6-4f08-b97b-0c37f877119f" providerId="ADAL" clId="{5F852C96-121E-4103-85D0-117B736085A1}" dt="2025-05-28T03:19:39.388" v="3571" actId="21"/>
-          <ac:picMkLst>
-            <pc:docMk/>
-            <pc:sldMk cId="2358797417" sldId="684"/>
-            <ac:picMk id="5" creationId="{7FDD7C87-6909-64CA-A587-61A30C42F2BE}"/>
-          </ac:picMkLst>
-        </pc:picChg>
       </pc:sldChg>
       <pc:sldChg chg="addSp modSp del mod modTransition">
         <pc:chgData name="Mohammed Fasha" userId="cc64f42d-a1a6-4f08-b97b-0c37f877119f" providerId="ADAL" clId="{5F852C96-121E-4103-85D0-117B736085A1}" dt="2025-05-28T02:57:35.487" v="3376" actId="2696"/>
@@ -1442,22 +1379,6 @@
           <pc:docMk/>
           <pc:sldMk cId="2404105392" sldId="685"/>
         </pc:sldMkLst>
-        <pc:spChg chg="mod">
-          <ac:chgData name="Mohammed Fasha" userId="cc64f42d-a1a6-4f08-b97b-0c37f877119f" providerId="ADAL" clId="{5F852C96-121E-4103-85D0-117B736085A1}" dt="2025-05-28T03:02:44.884" v="3464" actId="20577"/>
-          <ac:spMkLst>
-            <pc:docMk/>
-            <pc:sldMk cId="2404105392" sldId="685"/>
-            <ac:spMk id="3" creationId="{29EA7011-F30A-B5BD-7916-BEDAAC688CE5}"/>
-          </ac:spMkLst>
-        </pc:spChg>
-        <pc:picChg chg="del">
-          <ac:chgData name="Mohammed Fasha" userId="cc64f42d-a1a6-4f08-b97b-0c37f877119f" providerId="ADAL" clId="{5F852C96-121E-4103-85D0-117B736085A1}" dt="2025-05-28T03:01:07.040" v="3379" actId="21"/>
-          <ac:picMkLst>
-            <pc:docMk/>
-            <pc:sldMk cId="2404105392" sldId="685"/>
-            <ac:picMk id="1026" creationId="{4777CF26-0F99-41D1-84BC-BEB619F5AAA3}"/>
-          </ac:picMkLst>
-        </pc:picChg>
       </pc:sldChg>
       <pc:sldChg chg="addSp delSp modSp add mod ord">
         <pc:chgData name="Mohammed Fasha" userId="cc64f42d-a1a6-4f08-b97b-0c37f877119f" providerId="ADAL" clId="{5F852C96-121E-4103-85D0-117B736085A1}" dt="2025-05-28T03:26:06.400" v="3896" actId="20577"/>
@@ -1489,22 +1410,6 @@
             <ac:spMk id="8" creationId="{32EAD1AB-D386-174E-1FBD-A306B1F1B8CA}"/>
           </ac:spMkLst>
         </pc:spChg>
-        <pc:spChg chg="add del mod">
-          <ac:chgData name="Mohammed Fasha" userId="cc64f42d-a1a6-4f08-b97b-0c37f877119f" providerId="ADAL" clId="{5F852C96-121E-4103-85D0-117B736085A1}" dt="2025-05-28T03:25:43.815" v="3886"/>
-          <ac:spMkLst>
-            <pc:docMk/>
-            <pc:sldMk cId="212441645" sldId="686"/>
-            <ac:spMk id="11" creationId="{3E717736-76D3-9983-ADD6-F15AA1794990}"/>
-          </ac:spMkLst>
-        </pc:spChg>
-        <pc:picChg chg="add del mod">
-          <ac:chgData name="Mohammed Fasha" userId="cc64f42d-a1a6-4f08-b97b-0c37f877119f" providerId="ADAL" clId="{5F852C96-121E-4103-85D0-117B736085A1}" dt="2025-05-28T03:23:00.992" v="3828" actId="478"/>
-          <ac:picMkLst>
-            <pc:docMk/>
-            <pc:sldMk cId="212441645" sldId="686"/>
-            <ac:picMk id="5" creationId="{7FDD7C87-6909-64CA-A587-61A30C42F2BE}"/>
-          </ac:picMkLst>
-        </pc:picChg>
         <pc:picChg chg="add mod">
           <ac:chgData name="Mohammed Fasha" userId="cc64f42d-a1a6-4f08-b97b-0c37f877119f" providerId="ADAL" clId="{5F852C96-121E-4103-85D0-117B736085A1}" dt="2025-05-28T03:25:56.023" v="3890" actId="1076"/>
           <ac:picMkLst>
@@ -1542,30 +1447,6 @@
           <pc:docMk/>
           <pc:sldMk cId="1627958079" sldId="687"/>
         </pc:sldMkLst>
-        <pc:spChg chg="add del mod">
-          <ac:chgData name="Mohammed Fasha" userId="cc64f42d-a1a6-4f08-b97b-0c37f877119f" providerId="ADAL" clId="{5F852C96-121E-4103-85D0-117B736085A1}" dt="2025-05-28T03:29:05.491" v="4096" actId="21"/>
-          <ac:spMkLst>
-            <pc:docMk/>
-            <pc:sldMk cId="1627958079" sldId="687"/>
-            <ac:spMk id="4" creationId="{EB3A3DFD-8CF7-1353-0605-F13B64E5ACA7}"/>
-          </ac:spMkLst>
-        </pc:spChg>
-        <pc:picChg chg="del mod">
-          <ac:chgData name="Mohammed Fasha" userId="cc64f42d-a1a6-4f08-b97b-0c37f877119f" providerId="ADAL" clId="{5F852C96-121E-4103-85D0-117B736085A1}" dt="2025-05-28T03:26:29.733" v="3900" actId="21"/>
-          <ac:picMkLst>
-            <pc:docMk/>
-            <pc:sldMk cId="1627958079" sldId="687"/>
-            <ac:picMk id="5" creationId="{B636DED6-2E8E-111D-7C5D-408A3130139F}"/>
-          </ac:picMkLst>
-        </pc:picChg>
-        <pc:picChg chg="add del mod">
-          <ac:chgData name="Mohammed Fasha" userId="cc64f42d-a1a6-4f08-b97b-0c37f877119f" providerId="ADAL" clId="{5F852C96-121E-4103-85D0-117B736085A1}" dt="2025-05-28T03:29:06.765" v="4097" actId="21"/>
-          <ac:picMkLst>
-            <pc:docMk/>
-            <pc:sldMk cId="1627958079" sldId="687"/>
-            <ac:picMk id="1026" creationId="{4777CF26-0F99-41D1-84BC-BEB619F5AAA3}"/>
-          </ac:picMkLst>
-        </pc:picChg>
       </pc:sldChg>
       <pc:sldChg chg="del modTransition">
         <pc:chgData name="Mohammed Fasha" userId="cc64f42d-a1a6-4f08-b97b-0c37f877119f" providerId="ADAL" clId="{5F852C96-121E-4103-85D0-117B736085A1}" dt="2025-05-28T02:57:35.487" v="3376" actId="2696"/>
@@ -2382,22 +2263,6 @@
           <pc:docMk/>
           <pc:sldMk cId="921902307" sldId="761"/>
         </pc:sldMkLst>
-        <pc:spChg chg="mod">
-          <ac:chgData name="Mohammed Fasha" userId="cc64f42d-a1a6-4f08-b97b-0c37f877119f" providerId="ADAL" clId="{5F852C96-121E-4103-85D0-117B736085A1}" dt="2025-05-28T03:01:13.439" v="3380" actId="14100"/>
-          <ac:spMkLst>
-            <pc:docMk/>
-            <pc:sldMk cId="921902307" sldId="761"/>
-            <ac:spMk id="3" creationId="{9B3B1386-FDCB-CC6F-8391-F7659ABC5C24}"/>
-          </ac:spMkLst>
-        </pc:spChg>
-        <pc:picChg chg="add del mod">
-          <ac:chgData name="Mohammed Fasha" userId="cc64f42d-a1a6-4f08-b97b-0c37f877119f" providerId="ADAL" clId="{5F852C96-121E-4103-85D0-117B736085A1}" dt="2025-05-28T03:18:54.974" v="3563" actId="21"/>
-          <ac:picMkLst>
-            <pc:docMk/>
-            <pc:sldMk cId="921902307" sldId="761"/>
-            <ac:picMk id="1026" creationId="{4777CF26-0F99-41D1-84BC-BEB619F5AAA3}"/>
-          </ac:picMkLst>
-        </pc:picChg>
       </pc:sldChg>
       <pc:sldChg chg="addSp delSp modSp new del mod ord">
         <pc:chgData name="Mohammed Fasha" userId="cc64f42d-a1a6-4f08-b97b-0c37f877119f" providerId="ADAL" clId="{5F852C96-121E-4103-85D0-117B736085A1}" dt="2025-05-28T03:16:57.480" v="3493" actId="47"/>
@@ -2405,22 +2270,6 @@
           <pc:docMk/>
           <pc:sldMk cId="2362727324" sldId="762"/>
         </pc:sldMkLst>
-        <pc:spChg chg="mod">
-          <ac:chgData name="Mohammed Fasha" userId="cc64f42d-a1a6-4f08-b97b-0c37f877119f" providerId="ADAL" clId="{5F852C96-121E-4103-85D0-117B736085A1}" dt="2025-05-28T03:16:28.192" v="3482" actId="21"/>
-          <ac:spMkLst>
-            <pc:docMk/>
-            <pc:sldMk cId="2362727324" sldId="762"/>
-            <ac:spMk id="3" creationId="{C1D01C32-C489-3D74-5A42-1BEC84371736}"/>
-          </ac:spMkLst>
-        </pc:spChg>
-        <pc:spChg chg="add del mod">
-          <ac:chgData name="Mohammed Fasha" userId="cc64f42d-a1a6-4f08-b97b-0c37f877119f" providerId="ADAL" clId="{5F852C96-121E-4103-85D0-117B736085A1}" dt="2025-05-28T03:16:50.437" v="3489"/>
-          <ac:spMkLst>
-            <pc:docMk/>
-            <pc:sldMk cId="2362727324" sldId="762"/>
-            <ac:spMk id="5" creationId="{83628866-6006-D889-F263-A1F43BD016B7}"/>
-          </ac:spMkLst>
-        </pc:spChg>
       </pc:sldChg>
       <pc:sldChg chg="modSp new mod">
         <pc:chgData name="Mohammed Fasha" userId="cc64f42d-a1a6-4f08-b97b-0c37f877119f" providerId="ADAL" clId="{5F852C96-121E-4103-85D0-117B736085A1}" dt="2025-05-28T03:17:59.348" v="3560" actId="14100"/>
@@ -2467,14 +2316,6 @@
             <ac:spMk id="3" creationId="{A4D9427E-822D-DC27-3AF3-D10F44CC2B2A}"/>
           </ac:spMkLst>
         </pc:spChg>
-        <pc:picChg chg="add del mod">
-          <ac:chgData name="Mohammed Fasha" userId="cc64f42d-a1a6-4f08-b97b-0c37f877119f" providerId="ADAL" clId="{5F852C96-121E-4103-85D0-117B736085A1}" dt="2025-05-28T03:28:59.490" v="4094" actId="478"/>
-          <ac:picMkLst>
-            <pc:docMk/>
-            <pc:sldMk cId="251073540" sldId="764"/>
-            <ac:picMk id="5" creationId="{B636DED6-2E8E-111D-7C5D-408A3130139F}"/>
-          </ac:picMkLst>
-        </pc:picChg>
         <pc:picChg chg="add mod">
           <ac:chgData name="Mohammed Fasha" userId="cc64f42d-a1a6-4f08-b97b-0c37f877119f" providerId="ADAL" clId="{5F852C96-121E-4103-85D0-117B736085A1}" dt="2025-05-28T03:29:18.442" v="4100" actId="1076"/>
           <ac:picMkLst>
@@ -2489,14 +2330,6 @@
             <pc:docMk/>
             <pc:sldMk cId="251073540" sldId="764"/>
             <ac:picMk id="8" creationId="{3503F2F4-1CF2-C07A-6FE4-4C7B558CD167}"/>
-          </ac:picMkLst>
-        </pc:picChg>
-        <pc:picChg chg="add del mod">
-          <ac:chgData name="Mohammed Fasha" userId="cc64f42d-a1a6-4f08-b97b-0c37f877119f" providerId="ADAL" clId="{5F852C96-121E-4103-85D0-117B736085A1}" dt="2025-05-28T03:30:40.251" v="4105" actId="478"/>
-          <ac:picMkLst>
-            <pc:docMk/>
-            <pc:sldMk cId="251073540" sldId="764"/>
-            <ac:picMk id="1026" creationId="{4777CF26-0F99-41D1-84BC-BEB619F5AAA3}"/>
           </ac:picMkLst>
         </pc:picChg>
       </pc:sldChg>
@@ -2514,14 +2347,6 @@
             <ac:spMk id="2" creationId="{6A09C20C-3375-A97D-753A-CB94C194E76C}"/>
           </ac:spMkLst>
         </pc:spChg>
-        <pc:spChg chg="del">
-          <ac:chgData name="Mohammed Fasha" userId="cc64f42d-a1a6-4f08-b97b-0c37f877119f" providerId="ADAL" clId="{5F852C96-121E-4103-85D0-117B736085A1}" dt="2025-05-28T03:40:23.501" v="4163"/>
-          <ac:spMkLst>
-            <pc:docMk/>
-            <pc:sldMk cId="3984122067" sldId="765"/>
-            <ac:spMk id="3" creationId="{E7A9B254-605E-EA65-8134-E6E64727A239}"/>
-          </ac:spMkLst>
-        </pc:spChg>
         <pc:graphicFrameChg chg="add mod modGraphic">
           <ac:chgData name="Mohammed Fasha" userId="cc64f42d-a1a6-4f08-b97b-0c37f877119f" providerId="ADAL" clId="{5F852C96-121E-4103-85D0-117B736085A1}" dt="2025-05-28T03:43:10.744" v="4224" actId="122"/>
           <ac:graphicFrameMkLst>
@@ -2536,6 +2361,37 @@
             <pc:docMk/>
             <pc:sldMk cId="3984122067" sldId="765"/>
             <ac:picMk id="6" creationId="{1D0DB4D0-89DB-90EA-1172-A91873E8972E}"/>
+          </ac:picMkLst>
+        </pc:picChg>
+      </pc:sldChg>
+      <pc:sldChg chg="addSp delSp modSp new mod">
+        <pc:chgData name="Mohammed Fasha" userId="cc64f42d-a1a6-4f08-b97b-0c37f877119f" providerId="ADAL" clId="{5F852C96-121E-4103-85D0-117B736085A1}" dt="2025-06-03T05:07:41.628" v="4263" actId="20577"/>
+        <pc:sldMkLst>
+          <pc:docMk/>
+          <pc:sldMk cId="1914123317" sldId="766"/>
+        </pc:sldMkLst>
+        <pc:spChg chg="mod">
+          <ac:chgData name="Mohammed Fasha" userId="cc64f42d-a1a6-4f08-b97b-0c37f877119f" providerId="ADAL" clId="{5F852C96-121E-4103-85D0-117B736085A1}" dt="2025-06-03T05:07:41.628" v="4263" actId="20577"/>
+          <ac:spMkLst>
+            <pc:docMk/>
+            <pc:sldMk cId="1914123317" sldId="766"/>
+            <ac:spMk id="2" creationId="{30640AFD-69EB-FCBF-F4A6-0C9EC94F72E2}"/>
+          </ac:spMkLst>
+        </pc:spChg>
+        <pc:spChg chg="del">
+          <ac:chgData name="Mohammed Fasha" userId="cc64f42d-a1a6-4f08-b97b-0c37f877119f" providerId="ADAL" clId="{5F852C96-121E-4103-85D0-117B736085A1}" dt="2025-06-03T05:07:25.520" v="4227" actId="22"/>
+          <ac:spMkLst>
+            <pc:docMk/>
+            <pc:sldMk cId="1914123317" sldId="766"/>
+            <ac:spMk id="3" creationId="{55E6F6C4-55D2-CA0F-CE45-12C390F3DA33}"/>
+          </ac:spMkLst>
+        </pc:spChg>
+        <pc:picChg chg="add mod ord">
+          <ac:chgData name="Mohammed Fasha" userId="cc64f42d-a1a6-4f08-b97b-0c37f877119f" providerId="ADAL" clId="{5F852C96-121E-4103-85D0-117B736085A1}" dt="2025-06-03T05:07:25.520" v="4227" actId="22"/>
+          <ac:picMkLst>
+            <pc:docMk/>
+            <pc:sldMk cId="1914123317" sldId="766"/>
+            <ac:picMk id="5" creationId="{A9D6D904-9FA9-62A9-ACD9-BC69BF9FA60A}"/>
           </ac:picMkLst>
         </pc:picChg>
       </pc:sldChg>
@@ -3820,7 +3676,7 @@
           <a:p>
             <a:fld id="{13BA03A4-B9F1-404C-8A74-B1AFD6480953}" type="datetimeFigureOut">
               <a:rPr lang="en-US" smtClean="0"/>
-              <a:t>5/28/2025</a:t>
+              <a:t>6/3/2025</a:t>
             </a:fld>
             <a:endParaRPr lang="en-US"/>
           </a:p>
@@ -4318,7 +4174,7 @@
           <a:p>
             <a:fld id="{0DB78E95-DE77-44D3-BDB9-E242948FB112}" type="datetimeFigureOut">
               <a:rPr lang="en-US" smtClean="0"/>
-              <a:t>5/28/2025</a:t>
+              <a:t>6/3/2025</a:t>
             </a:fld>
             <a:endParaRPr lang="en-US"/>
           </a:p>
@@ -4546,7 +4402,7 @@
           <a:p>
             <a:fld id="{0DB78E95-DE77-44D3-BDB9-E242948FB112}" type="datetimeFigureOut">
               <a:rPr lang="en-US" smtClean="0"/>
-              <a:t>5/28/2025</a:t>
+              <a:t>6/3/2025</a:t>
             </a:fld>
             <a:endParaRPr lang="en-US"/>
           </a:p>
@@ -4754,7 +4610,7 @@
           <a:p>
             <a:fld id="{0DB78E95-DE77-44D3-BDB9-E242948FB112}" type="datetimeFigureOut">
               <a:rPr lang="en-US" smtClean="0"/>
-              <a:t>5/28/2025</a:t>
+              <a:t>6/3/2025</a:t>
             </a:fld>
             <a:endParaRPr lang="en-US"/>
           </a:p>
@@ -5185,7 +5041,7 @@
           <a:p>
             <a:fld id="{0DB78E95-DE77-44D3-BDB9-E242948FB112}" type="datetimeFigureOut">
               <a:rPr lang="en-US" smtClean="0"/>
-              <a:t>5/28/2025</a:t>
+              <a:t>6/3/2025</a:t>
             </a:fld>
             <a:endParaRPr lang="en-US"/>
           </a:p>
@@ -5564,7 +5420,7 @@
           <a:p>
             <a:fld id="{0DB78E95-DE77-44D3-BDB9-E242948FB112}" type="datetimeFigureOut">
               <a:rPr lang="en-US" smtClean="0"/>
-              <a:t>5/28/2025</a:t>
+              <a:t>6/3/2025</a:t>
             </a:fld>
             <a:endParaRPr lang="en-US"/>
           </a:p>
@@ -5976,7 +5832,7 @@
           <a:p>
             <a:fld id="{0DB78E95-DE77-44D3-BDB9-E242948FB112}" type="datetimeFigureOut">
               <a:rPr lang="en-US" smtClean="0"/>
-              <a:t>5/28/2025</a:t>
+              <a:t>6/3/2025</a:t>
             </a:fld>
             <a:endParaRPr lang="en-US"/>
           </a:p>
@@ -6117,7 +5973,7 @@
           <a:p>
             <a:fld id="{0DB78E95-DE77-44D3-BDB9-E242948FB112}" type="datetimeFigureOut">
               <a:rPr lang="en-US" smtClean="0"/>
-              <a:t>5/28/2025</a:t>
+              <a:t>6/3/2025</a:t>
             </a:fld>
             <a:endParaRPr lang="en-US"/>
           </a:p>
@@ -6230,7 +6086,7 @@
           <a:p>
             <a:fld id="{0DB78E95-DE77-44D3-BDB9-E242948FB112}" type="datetimeFigureOut">
               <a:rPr lang="en-US" smtClean="0"/>
-              <a:t>5/28/2025</a:t>
+              <a:t>6/3/2025</a:t>
             </a:fld>
             <a:endParaRPr lang="en-US"/>
           </a:p>
@@ -6541,7 +6397,7 @@
           <a:p>
             <a:fld id="{0DB78E95-DE77-44D3-BDB9-E242948FB112}" type="datetimeFigureOut">
               <a:rPr lang="en-US" smtClean="0"/>
-              <a:t>5/28/2025</a:t>
+              <a:t>6/3/2025</a:t>
             </a:fld>
             <a:endParaRPr lang="en-US"/>
           </a:p>
@@ -6829,7 +6685,7 @@
           <a:p>
             <a:fld id="{0DB78E95-DE77-44D3-BDB9-E242948FB112}" type="datetimeFigureOut">
               <a:rPr lang="en-US" smtClean="0"/>
-              <a:t>5/28/2025</a:t>
+              <a:t>6/3/2025</a:t>
             </a:fld>
             <a:endParaRPr lang="en-US"/>
           </a:p>
@@ -7070,7 +6926,7 @@
           <a:p>
             <a:fld id="{0DB78E95-DE77-44D3-BDB9-E242948FB112}" type="datetimeFigureOut">
               <a:rPr lang="en-US" smtClean="0"/>
-              <a:t>5/28/2025</a:t>
+              <a:t>6/3/2025</a:t>
             </a:fld>
             <a:endParaRPr lang="en-US"/>
           </a:p>
@@ -32986,6 +32842,93 @@
       </p:grpSpPr>
       <p:sp>
         <p:nvSpPr>
+          <p:cNvPr id="2" name="Title 1">
+            <a:extLst>
+              <a:ext uri="{FF2B5EF4-FFF2-40B4-BE49-F238E27FC236}">
+                <a16:creationId xmlns:a16="http://schemas.microsoft.com/office/drawing/2014/main" id="{30640AFD-69EB-FCBF-F4A6-0C9EC94F72E2}"/>
+              </a:ext>
+            </a:extLst>
+          </p:cNvPr>
+          <p:cNvSpPr>
+            <a:spLocks noGrp="1"/>
+          </p:cNvSpPr>
+          <p:nvPr>
+            <p:ph type="title"/>
+          </p:nvPr>
+        </p:nvSpPr>
+        <p:spPr/>
+        <p:txBody>
+          <a:bodyPr/>
+          <a:lstStyle/>
+          <a:p>
+            <a:r>
+              <a:rPr lang="en-US" dirty="0"/>
+              <a:t>Check the Solution in The Excel File</a:t>
+            </a:r>
+          </a:p>
+        </p:txBody>
+      </p:sp>
+      <p:pic>
+        <p:nvPicPr>
+          <p:cNvPr id="5" name="Content Placeholder 4">
+            <a:extLst>
+              <a:ext uri="{FF2B5EF4-FFF2-40B4-BE49-F238E27FC236}">
+                <a16:creationId xmlns:a16="http://schemas.microsoft.com/office/drawing/2014/main" id="{A9D6D904-9FA9-62A9-ACD9-BC69BF9FA60A}"/>
+              </a:ext>
+            </a:extLst>
+          </p:cNvPr>
+          <p:cNvPicPr>
+            <a:picLocks noGrp="1" noChangeAspect="1"/>
+          </p:cNvPicPr>
+          <p:nvPr>
+            <p:ph idx="1"/>
+          </p:nvPr>
+        </p:nvPicPr>
+        <p:blipFill>
+          <a:blip r:embed="rId2"/>
+          <a:stretch>
+            <a:fillRect/>
+          </a:stretch>
+        </p:blipFill>
+        <p:spPr>
+          <a:xfrm>
+            <a:off x="1466291" y="1706563"/>
+            <a:ext cx="9259418" cy="4991100"/>
+          </a:xfrm>
+        </p:spPr>
+      </p:pic>
+    </p:spTree>
+    <p:extLst>
+      <p:ext uri="{BB962C8B-B14F-4D97-AF65-F5344CB8AC3E}">
+        <p14:creationId xmlns:p14="http://schemas.microsoft.com/office/powerpoint/2010/main" val="1914123317"/>
+      </p:ext>
+    </p:extLst>
+  </p:cSld>
+  <p:clrMapOvr>
+    <a:masterClrMapping/>
+  </p:clrMapOvr>
+</p:sld>
+</file>
+
+<file path=ppt/slides/slide47.xml><?xml version="1.0" encoding="utf-8"?>
+<p:sld xmlns:a="http://schemas.openxmlformats.org/drawingml/2006/main" xmlns:r="http://schemas.openxmlformats.org/officeDocument/2006/relationships" xmlns:p="http://schemas.openxmlformats.org/presentationml/2006/main">
+  <p:cSld>
+    <p:spTree>
+      <p:nvGrpSpPr>
+        <p:cNvPr id="1" name=""/>
+        <p:cNvGrpSpPr/>
+        <p:nvPr/>
+      </p:nvGrpSpPr>
+      <p:grpSpPr>
+        <a:xfrm>
+          <a:off x="0" y="0"/>
+          <a:ext cx="0" cy="0"/>
+          <a:chOff x="0" y="0"/>
+          <a:chExt cx="0" cy="0"/>
+        </a:xfrm>
+      </p:grpSpPr>
+      <p:sp>
+        <p:nvSpPr>
           <p:cNvPr id="4" name="Title 3">
             <a:extLst>
               <a:ext uri="{FF2B5EF4-FFF2-40B4-BE49-F238E27FC236}">
@@ -33060,7 +33003,7 @@
 </p:sld>
 </file>
 
-<file path=ppt/slides/slide47.xml><?xml version="1.0" encoding="utf-8"?>
+<file path=ppt/slides/slide48.xml><?xml version="1.0" encoding="utf-8"?>
 <p:sld xmlns:a="http://schemas.openxmlformats.org/drawingml/2006/main" xmlns:r="http://schemas.openxmlformats.org/officeDocument/2006/relationships" xmlns:p="http://schemas.openxmlformats.org/presentationml/2006/main">
   <p:cSld>
     <p:spTree>
@@ -33200,7 +33143,7 @@
 </p:sld>
 </file>
 
-<file path=ppt/slides/slide48.xml><?xml version="1.0" encoding="utf-8"?>
+<file path=ppt/slides/slide49.xml><?xml version="1.0" encoding="utf-8"?>
 <p:sld xmlns:a="http://schemas.openxmlformats.org/drawingml/2006/main" xmlns:r="http://schemas.openxmlformats.org/officeDocument/2006/relationships" xmlns:p="http://schemas.openxmlformats.org/presentationml/2006/main">
   <p:cSld>
     <p:spTree>
@@ -33399,1075 +33342,6 @@
     <p:extLst>
       <p:ext uri="{BB962C8B-B14F-4D97-AF65-F5344CB8AC3E}">
         <p14:creationId xmlns:p14="http://schemas.microsoft.com/office/powerpoint/2010/main" val="1620993364"/>
-      </p:ext>
-    </p:extLst>
-  </p:cSld>
-  <p:clrMapOvr>
-    <a:masterClrMapping/>
-  </p:clrMapOvr>
-  <p:transition spd="med">
-    <p:pull/>
-  </p:transition>
-</p:sld>
-</file>
-
-<file path=ppt/slides/slide49.xml><?xml version="1.0" encoding="utf-8"?>
-<p:sld xmlns:a="http://schemas.openxmlformats.org/drawingml/2006/main" xmlns:r="http://schemas.openxmlformats.org/officeDocument/2006/relationships" xmlns:p="http://schemas.openxmlformats.org/presentationml/2006/main">
-  <p:cSld>
-    <p:spTree>
-      <p:nvGrpSpPr>
-        <p:cNvPr id="1" name=""/>
-        <p:cNvGrpSpPr/>
-        <p:nvPr/>
-      </p:nvGrpSpPr>
-      <p:grpSpPr>
-        <a:xfrm>
-          <a:off x="0" y="0"/>
-          <a:ext cx="0" cy="0"/>
-          <a:chOff x="0" y="0"/>
-          <a:chExt cx="0" cy="0"/>
-        </a:xfrm>
-      </p:grpSpPr>
-      <p:sp>
-        <p:nvSpPr>
-          <p:cNvPr id="2" name="Title 1">
-            <a:extLst>
-              <a:ext uri="{FF2B5EF4-FFF2-40B4-BE49-F238E27FC236}">
-                <a16:creationId xmlns:a16="http://schemas.microsoft.com/office/drawing/2014/main" id="{B27049DC-2646-5AA2-FEFD-C08185FCAF02}"/>
-              </a:ext>
-            </a:extLst>
-          </p:cNvPr>
-          <p:cNvSpPr>
-            <a:spLocks noGrp="1"/>
-          </p:cNvSpPr>
-          <p:nvPr>
-            <p:ph type="title"/>
-          </p:nvPr>
-        </p:nvSpPr>
-        <p:spPr/>
-        <p:txBody>
-          <a:bodyPr/>
-          <a:lstStyle/>
-          <a:p>
-            <a:r>
-              <a:rPr lang="en-US" dirty="0"/>
-              <a:t>ANOVA Example</a:t>
-            </a:r>
-          </a:p>
-        </p:txBody>
-      </p:sp>
-      <p:sp>
-        <p:nvSpPr>
-          <p:cNvPr id="3" name="Content Placeholder 2">
-            <a:extLst>
-              <a:ext uri="{FF2B5EF4-FFF2-40B4-BE49-F238E27FC236}">
-                <a16:creationId xmlns:a16="http://schemas.microsoft.com/office/drawing/2014/main" id="{4D106FBB-198D-A7E8-03C4-7101324CD9F3}"/>
-              </a:ext>
-            </a:extLst>
-          </p:cNvPr>
-          <p:cNvSpPr>
-            <a:spLocks noGrp="1"/>
-          </p:cNvSpPr>
-          <p:nvPr>
-            <p:ph idx="1"/>
-          </p:nvPr>
-        </p:nvSpPr>
-        <p:spPr>
-          <a:xfrm>
-            <a:off x="838199" y="1706007"/>
-            <a:ext cx="7631349" cy="4991039"/>
-          </a:xfrm>
-        </p:spPr>
-        <p:txBody>
-          <a:bodyPr>
-            <a:normAutofit/>
-          </a:bodyPr>
-          <a:lstStyle/>
-          <a:p>
-            <a:r>
-              <a:rPr lang="en-US" sz="2000" dirty="0"/>
-              <a:t>Scenario: A school tests three different teaching methods to determine which one results in the best performance on a standardized test. </a:t>
-            </a:r>
-          </a:p>
-          <a:p>
-            <a:r>
-              <a:rPr lang="en-US" sz="2000" dirty="0"/>
-              <a:t>The students are randomly assigned to one of three groups, each receiving instruction through a different method. </a:t>
-            </a:r>
-          </a:p>
-          <a:p>
-            <a:r>
-              <a:rPr lang="en-US" sz="2000" dirty="0"/>
-              <a:t>Their scores on a standardized test are recorded.</a:t>
-            </a:r>
-          </a:p>
-          <a:p>
-            <a:r>
-              <a:rPr lang="en-US" sz="2000" dirty="0"/>
-              <a:t>Variables:</a:t>
-            </a:r>
-          </a:p>
-          <a:p>
-            <a:pPr lvl="1"/>
-            <a:r>
-              <a:rPr lang="en-US" sz="1800" dirty="0"/>
-              <a:t>Group: The teaching method group (A, B, C)</a:t>
-            </a:r>
-          </a:p>
-          <a:p>
-            <a:pPr lvl="1"/>
-            <a:r>
-              <a:rPr lang="en-US" sz="1800" dirty="0"/>
-              <a:t>Score: The score each student received on the standardized test.</a:t>
-            </a:r>
-          </a:p>
-          <a:p>
-            <a:pPr lvl="1"/>
-            <a:endParaRPr lang="en-US" sz="1800" dirty="0"/>
-          </a:p>
-        </p:txBody>
-      </p:sp>
-      <p:graphicFrame>
-        <p:nvGraphicFramePr>
-          <p:cNvPr id="4" name="Table 3">
-            <a:extLst>
-              <a:ext uri="{FF2B5EF4-FFF2-40B4-BE49-F238E27FC236}">
-                <a16:creationId xmlns:a16="http://schemas.microsoft.com/office/drawing/2014/main" id="{23CF52D0-9903-D0FC-10CC-382F02269359}"/>
-              </a:ext>
-            </a:extLst>
-          </p:cNvPr>
-          <p:cNvGraphicFramePr>
-            <a:graphicFrameLocks noGrp="1"/>
-          </p:cNvGraphicFramePr>
-          <p:nvPr>
-            <p:extLst>
-              <p:ext uri="{D42A27DB-BD31-4B8C-83A1-F6EECF244321}">
-                <p14:modId xmlns:p14="http://schemas.microsoft.com/office/powerpoint/2010/main" val="2765110422"/>
-              </p:ext>
-            </p:extLst>
-          </p:nvPr>
-        </p:nvGraphicFramePr>
-        <p:xfrm>
-          <a:off x="9038422" y="1706007"/>
-          <a:ext cx="2224587" cy="4543615"/>
-        </p:xfrm>
-        <a:graphic>
-          <a:graphicData uri="http://schemas.openxmlformats.org/drawingml/2006/table">
-            <a:tbl>
-              <a:tblPr>
-                <a:tableStyleId>{9D7B26C5-4107-4FEC-AEDC-1716B250A1EF}</a:tableStyleId>
-              </a:tblPr>
-              <a:tblGrid>
-                <a:gridCol w="741529">
-                  <a:extLst>
-                    <a:ext uri="{9D8B030D-6E8A-4147-A177-3AD203B41FA5}">
-                      <a16:colId xmlns:a16="http://schemas.microsoft.com/office/drawing/2014/main" val="4040225334"/>
-                    </a:ext>
-                  </a:extLst>
-                </a:gridCol>
-                <a:gridCol w="741529">
-                  <a:extLst>
-                    <a:ext uri="{9D8B030D-6E8A-4147-A177-3AD203B41FA5}">
-                      <a16:colId xmlns:a16="http://schemas.microsoft.com/office/drawing/2014/main" val="2431098428"/>
-                    </a:ext>
-                  </a:extLst>
-                </a:gridCol>
-                <a:gridCol w="741529">
-                  <a:extLst>
-                    <a:ext uri="{9D8B030D-6E8A-4147-A177-3AD203B41FA5}">
-                      <a16:colId xmlns:a16="http://schemas.microsoft.com/office/drawing/2014/main" val="1990735719"/>
-                    </a:ext>
-                  </a:extLst>
-                </a:gridCol>
-              </a:tblGrid>
-              <a:tr h="271959">
-                <a:tc>
-                  <a:txBody>
-                    <a:bodyPr/>
-                    <a:lstStyle/>
-                    <a:p>
-                      <a:pPr fontAlgn="b"/>
-                      <a:r>
-                        <a:rPr lang="en-US" sz="1300" b="1">
-                          <a:effectLst/>
-                        </a:rPr>
-                        <a:t>Student ID</a:t>
-                      </a:r>
-                    </a:p>
-                  </a:txBody>
-                  <a:tcPr marL="67990" marR="67990" marT="33995" marB="33995" anchor="b"/>
-                </a:tc>
-                <a:tc>
-                  <a:txBody>
-                    <a:bodyPr/>
-                    <a:lstStyle/>
-                    <a:p>
-                      <a:pPr fontAlgn="b"/>
-                      <a:r>
-                        <a:rPr lang="en-US" sz="1300" b="1">
-                          <a:effectLst/>
-                        </a:rPr>
-                        <a:t>Group</a:t>
-                      </a:r>
-                    </a:p>
-                  </a:txBody>
-                  <a:tcPr marL="67990" marR="67990" marT="33995" marB="33995" anchor="b"/>
-                </a:tc>
-                <a:tc>
-                  <a:txBody>
-                    <a:bodyPr/>
-                    <a:lstStyle/>
-                    <a:p>
-                      <a:pPr fontAlgn="b"/>
-                      <a:r>
-                        <a:rPr lang="en-US" sz="1300" b="1">
-                          <a:effectLst/>
-                        </a:rPr>
-                        <a:t>Score</a:t>
-                      </a:r>
-                    </a:p>
-                  </a:txBody>
-                  <a:tcPr marL="67990" marR="67990" marT="33995" marB="33995" anchor="b"/>
-                </a:tc>
-                <a:extLst>
-                  <a:ext uri="{0D108BD9-81ED-4DB2-BD59-A6C34878D82A}">
-                    <a16:rowId xmlns:a16="http://schemas.microsoft.com/office/drawing/2014/main" val="2519526074"/>
-                  </a:ext>
-                </a:extLst>
-              </a:tr>
-              <a:tr h="271959">
-                <a:tc>
-                  <a:txBody>
-                    <a:bodyPr/>
-                    <a:lstStyle/>
-                    <a:p>
-                      <a:pPr fontAlgn="base"/>
-                      <a:r>
-                        <a:rPr lang="en-US" sz="1300">
-                          <a:effectLst/>
-                        </a:rPr>
-                        <a:t>1</a:t>
-                      </a:r>
-                    </a:p>
-                  </a:txBody>
-                  <a:tcPr marL="67990" marR="67990" marT="33995" marB="33995" anchor="ctr"/>
-                </a:tc>
-                <a:tc>
-                  <a:txBody>
-                    <a:bodyPr/>
-                    <a:lstStyle/>
-                    <a:p>
-                      <a:pPr fontAlgn="base"/>
-                      <a:r>
-                        <a:rPr lang="en-US" sz="1300">
-                          <a:effectLst/>
-                        </a:rPr>
-                        <a:t>A</a:t>
-                      </a:r>
-                    </a:p>
-                  </a:txBody>
-                  <a:tcPr marL="67990" marR="67990" marT="33995" marB="33995" anchor="ctr"/>
-                </a:tc>
-                <a:tc>
-                  <a:txBody>
-                    <a:bodyPr/>
-                    <a:lstStyle/>
-                    <a:p>
-                      <a:pPr fontAlgn="base"/>
-                      <a:r>
-                        <a:rPr lang="en-US" sz="1300">
-                          <a:effectLst/>
-                        </a:rPr>
-                        <a:t>82</a:t>
-                      </a:r>
-                    </a:p>
-                  </a:txBody>
-                  <a:tcPr marL="67990" marR="67990" marT="33995" marB="33995" anchor="ctr"/>
-                </a:tc>
-                <a:extLst>
-                  <a:ext uri="{0D108BD9-81ED-4DB2-BD59-A6C34878D82A}">
-                    <a16:rowId xmlns:a16="http://schemas.microsoft.com/office/drawing/2014/main" val="2379991012"/>
-                  </a:ext>
-                </a:extLst>
-              </a:tr>
-              <a:tr h="271959">
-                <a:tc>
-                  <a:txBody>
-                    <a:bodyPr/>
-                    <a:lstStyle/>
-                    <a:p>
-                      <a:pPr fontAlgn="base"/>
-                      <a:r>
-                        <a:rPr lang="en-US" sz="1300">
-                          <a:effectLst/>
-                        </a:rPr>
-                        <a:t>2</a:t>
-                      </a:r>
-                    </a:p>
-                  </a:txBody>
-                  <a:tcPr marL="67990" marR="67990" marT="33995" marB="33995" anchor="ctr"/>
-                </a:tc>
-                <a:tc>
-                  <a:txBody>
-                    <a:bodyPr/>
-                    <a:lstStyle/>
-                    <a:p>
-                      <a:pPr fontAlgn="base"/>
-                      <a:r>
-                        <a:rPr lang="en-US" sz="1300">
-                          <a:effectLst/>
-                        </a:rPr>
-                        <a:t>A</a:t>
-                      </a:r>
-                    </a:p>
-                  </a:txBody>
-                  <a:tcPr marL="67990" marR="67990" marT="33995" marB="33995" anchor="ctr"/>
-                </a:tc>
-                <a:tc>
-                  <a:txBody>
-                    <a:bodyPr/>
-                    <a:lstStyle/>
-                    <a:p>
-                      <a:pPr fontAlgn="base"/>
-                      <a:r>
-                        <a:rPr lang="en-US" sz="1300">
-                          <a:effectLst/>
-                        </a:rPr>
-                        <a:t>88</a:t>
-                      </a:r>
-                    </a:p>
-                  </a:txBody>
-                  <a:tcPr marL="67990" marR="67990" marT="33995" marB="33995" anchor="ctr"/>
-                </a:tc>
-                <a:extLst>
-                  <a:ext uri="{0D108BD9-81ED-4DB2-BD59-A6C34878D82A}">
-                    <a16:rowId xmlns:a16="http://schemas.microsoft.com/office/drawing/2014/main" val="3645977183"/>
-                  </a:ext>
-                </a:extLst>
-              </a:tr>
-              <a:tr h="271959">
-                <a:tc>
-                  <a:txBody>
-                    <a:bodyPr/>
-                    <a:lstStyle/>
-                    <a:p>
-                      <a:pPr fontAlgn="base"/>
-                      <a:r>
-                        <a:rPr lang="en-US" sz="1300">
-                          <a:effectLst/>
-                        </a:rPr>
-                        <a:t>3</a:t>
-                      </a:r>
-                    </a:p>
-                  </a:txBody>
-                  <a:tcPr marL="67990" marR="67990" marT="33995" marB="33995" anchor="ctr"/>
-                </a:tc>
-                <a:tc>
-                  <a:txBody>
-                    <a:bodyPr/>
-                    <a:lstStyle/>
-                    <a:p>
-                      <a:pPr fontAlgn="base"/>
-                      <a:r>
-                        <a:rPr lang="en-US" sz="1300">
-                          <a:effectLst/>
-                        </a:rPr>
-                        <a:t>A</a:t>
-                      </a:r>
-                    </a:p>
-                  </a:txBody>
-                  <a:tcPr marL="67990" marR="67990" marT="33995" marB="33995" anchor="ctr"/>
-                </a:tc>
-                <a:tc>
-                  <a:txBody>
-                    <a:bodyPr/>
-                    <a:lstStyle/>
-                    <a:p>
-                      <a:pPr fontAlgn="base"/>
-                      <a:r>
-                        <a:rPr lang="en-US" sz="1300">
-                          <a:effectLst/>
-                        </a:rPr>
-                        <a:t>84</a:t>
-                      </a:r>
-                    </a:p>
-                  </a:txBody>
-                  <a:tcPr marL="67990" marR="67990" marT="33995" marB="33995" anchor="ctr"/>
-                </a:tc>
-                <a:extLst>
-                  <a:ext uri="{0D108BD9-81ED-4DB2-BD59-A6C34878D82A}">
-                    <a16:rowId xmlns:a16="http://schemas.microsoft.com/office/drawing/2014/main" val="2127075430"/>
-                  </a:ext>
-                </a:extLst>
-              </a:tr>
-              <a:tr h="271959">
-                <a:tc>
-                  <a:txBody>
-                    <a:bodyPr/>
-                    <a:lstStyle/>
-                    <a:p>
-                      <a:pPr fontAlgn="base"/>
-                      <a:r>
-                        <a:rPr lang="en-US" sz="1300">
-                          <a:effectLst/>
-                        </a:rPr>
-                        <a:t>4</a:t>
-                      </a:r>
-                    </a:p>
-                  </a:txBody>
-                  <a:tcPr marL="67990" marR="67990" marT="33995" marB="33995" anchor="ctr"/>
-                </a:tc>
-                <a:tc>
-                  <a:txBody>
-                    <a:bodyPr/>
-                    <a:lstStyle/>
-                    <a:p>
-                      <a:pPr fontAlgn="base"/>
-                      <a:r>
-                        <a:rPr lang="en-US" sz="1300">
-                          <a:effectLst/>
-                        </a:rPr>
-                        <a:t>A</a:t>
-                      </a:r>
-                    </a:p>
-                  </a:txBody>
-                  <a:tcPr marL="67990" marR="67990" marT="33995" marB="33995" anchor="ctr"/>
-                </a:tc>
-                <a:tc>
-                  <a:txBody>
-                    <a:bodyPr/>
-                    <a:lstStyle/>
-                    <a:p>
-                      <a:pPr fontAlgn="base"/>
-                      <a:r>
-                        <a:rPr lang="en-US" sz="1300">
-                          <a:effectLst/>
-                        </a:rPr>
-                        <a:t>90</a:t>
-                      </a:r>
-                    </a:p>
-                  </a:txBody>
-                  <a:tcPr marL="67990" marR="67990" marT="33995" marB="33995" anchor="ctr"/>
-                </a:tc>
-                <a:extLst>
-                  <a:ext uri="{0D108BD9-81ED-4DB2-BD59-A6C34878D82A}">
-                    <a16:rowId xmlns:a16="http://schemas.microsoft.com/office/drawing/2014/main" val="608421500"/>
-                  </a:ext>
-                </a:extLst>
-              </a:tr>
-              <a:tr h="271959">
-                <a:tc>
-                  <a:txBody>
-                    <a:bodyPr/>
-                    <a:lstStyle/>
-                    <a:p>
-                      <a:pPr fontAlgn="base"/>
-                      <a:r>
-                        <a:rPr lang="en-US" sz="1300">
-                          <a:effectLst/>
-                        </a:rPr>
-                        <a:t>5</a:t>
-                      </a:r>
-                    </a:p>
-                  </a:txBody>
-                  <a:tcPr marL="67990" marR="67990" marT="33995" marB="33995" anchor="ctr"/>
-                </a:tc>
-                <a:tc>
-                  <a:txBody>
-                    <a:bodyPr/>
-                    <a:lstStyle/>
-                    <a:p>
-                      <a:pPr fontAlgn="base"/>
-                      <a:r>
-                        <a:rPr lang="en-US" sz="1300">
-                          <a:effectLst/>
-                        </a:rPr>
-                        <a:t>A</a:t>
-                      </a:r>
-                    </a:p>
-                  </a:txBody>
-                  <a:tcPr marL="67990" marR="67990" marT="33995" marB="33995" anchor="ctr"/>
-                </a:tc>
-                <a:tc>
-                  <a:txBody>
-                    <a:bodyPr/>
-                    <a:lstStyle/>
-                    <a:p>
-                      <a:pPr fontAlgn="base"/>
-                      <a:r>
-                        <a:rPr lang="en-US" sz="1300">
-                          <a:effectLst/>
-                        </a:rPr>
-                        <a:t>85</a:t>
-                      </a:r>
-                    </a:p>
-                  </a:txBody>
-                  <a:tcPr marL="67990" marR="67990" marT="33995" marB="33995" anchor="ctr"/>
-                </a:tc>
-                <a:extLst>
-                  <a:ext uri="{0D108BD9-81ED-4DB2-BD59-A6C34878D82A}">
-                    <a16:rowId xmlns:a16="http://schemas.microsoft.com/office/drawing/2014/main" val="4028156413"/>
-                  </a:ext>
-                </a:extLst>
-              </a:tr>
-              <a:tr h="271959">
-                <a:tc>
-                  <a:txBody>
-                    <a:bodyPr/>
-                    <a:lstStyle/>
-                    <a:p>
-                      <a:pPr fontAlgn="base"/>
-                      <a:r>
-                        <a:rPr lang="en-US" sz="1300">
-                          <a:effectLst/>
-                        </a:rPr>
-                        <a:t>6</a:t>
-                      </a:r>
-                    </a:p>
-                  </a:txBody>
-                  <a:tcPr marL="67990" marR="67990" marT="33995" marB="33995" anchor="ctr"/>
-                </a:tc>
-                <a:tc>
-                  <a:txBody>
-                    <a:bodyPr/>
-                    <a:lstStyle/>
-                    <a:p>
-                      <a:pPr fontAlgn="base"/>
-                      <a:r>
-                        <a:rPr lang="en-US" sz="1300">
-                          <a:effectLst/>
-                        </a:rPr>
-                        <a:t>B</a:t>
-                      </a:r>
-                    </a:p>
-                  </a:txBody>
-                  <a:tcPr marL="67990" marR="67990" marT="33995" marB="33995" anchor="ctr"/>
-                </a:tc>
-                <a:tc>
-                  <a:txBody>
-                    <a:bodyPr/>
-                    <a:lstStyle/>
-                    <a:p>
-                      <a:pPr fontAlgn="base"/>
-                      <a:r>
-                        <a:rPr lang="en-US" sz="1300" dirty="0">
-                          <a:effectLst/>
-                        </a:rPr>
-                        <a:t>78</a:t>
-                      </a:r>
-                    </a:p>
-                  </a:txBody>
-                  <a:tcPr marL="67990" marR="67990" marT="33995" marB="33995" anchor="ctr"/>
-                </a:tc>
-                <a:extLst>
-                  <a:ext uri="{0D108BD9-81ED-4DB2-BD59-A6C34878D82A}">
-                    <a16:rowId xmlns:a16="http://schemas.microsoft.com/office/drawing/2014/main" val="1234083821"/>
-                  </a:ext>
-                </a:extLst>
-              </a:tr>
-              <a:tr h="271959">
-                <a:tc>
-                  <a:txBody>
-                    <a:bodyPr/>
-                    <a:lstStyle/>
-                    <a:p>
-                      <a:pPr fontAlgn="base"/>
-                      <a:r>
-                        <a:rPr lang="en-US" sz="1300" dirty="0">
-                          <a:effectLst/>
-                        </a:rPr>
-                        <a:t>7</a:t>
-                      </a:r>
-                    </a:p>
-                  </a:txBody>
-                  <a:tcPr marL="67990" marR="67990" marT="33995" marB="33995" anchor="ctr"/>
-                </a:tc>
-                <a:tc>
-                  <a:txBody>
-                    <a:bodyPr/>
-                    <a:lstStyle/>
-                    <a:p>
-                      <a:pPr fontAlgn="base"/>
-                      <a:r>
-                        <a:rPr lang="en-US" sz="1300">
-                          <a:effectLst/>
-                        </a:rPr>
-                        <a:t>B</a:t>
-                      </a:r>
-                    </a:p>
-                  </a:txBody>
-                  <a:tcPr marL="67990" marR="67990" marT="33995" marB="33995" anchor="ctr"/>
-                </a:tc>
-                <a:tc>
-                  <a:txBody>
-                    <a:bodyPr/>
-                    <a:lstStyle/>
-                    <a:p>
-                      <a:pPr fontAlgn="base"/>
-                      <a:r>
-                        <a:rPr lang="en-US" sz="1300">
-                          <a:effectLst/>
-                        </a:rPr>
-                        <a:t>75</a:t>
-                      </a:r>
-                    </a:p>
-                  </a:txBody>
-                  <a:tcPr marL="67990" marR="67990" marT="33995" marB="33995" anchor="ctr"/>
-                </a:tc>
-                <a:extLst>
-                  <a:ext uri="{0D108BD9-81ED-4DB2-BD59-A6C34878D82A}">
-                    <a16:rowId xmlns:a16="http://schemas.microsoft.com/office/drawing/2014/main" val="3431443898"/>
-                  </a:ext>
-                </a:extLst>
-              </a:tr>
-              <a:tr h="271959">
-                <a:tc>
-                  <a:txBody>
-                    <a:bodyPr/>
-                    <a:lstStyle/>
-                    <a:p>
-                      <a:pPr fontAlgn="base"/>
-                      <a:r>
-                        <a:rPr lang="en-US" sz="1300">
-                          <a:effectLst/>
-                        </a:rPr>
-                        <a:t>8</a:t>
-                      </a:r>
-                    </a:p>
-                  </a:txBody>
-                  <a:tcPr marL="67990" marR="67990" marT="33995" marB="33995" anchor="ctr"/>
-                </a:tc>
-                <a:tc>
-                  <a:txBody>
-                    <a:bodyPr/>
-                    <a:lstStyle/>
-                    <a:p>
-                      <a:pPr fontAlgn="base"/>
-                      <a:r>
-                        <a:rPr lang="en-US" sz="1300">
-                          <a:effectLst/>
-                        </a:rPr>
-                        <a:t>B</a:t>
-                      </a:r>
-                    </a:p>
-                  </a:txBody>
-                  <a:tcPr marL="67990" marR="67990" marT="33995" marB="33995" anchor="ctr"/>
-                </a:tc>
-                <a:tc>
-                  <a:txBody>
-                    <a:bodyPr/>
-                    <a:lstStyle/>
-                    <a:p>
-                      <a:pPr fontAlgn="base"/>
-                      <a:r>
-                        <a:rPr lang="en-US" sz="1300">
-                          <a:effectLst/>
-                        </a:rPr>
-                        <a:t>80</a:t>
-                      </a:r>
-                    </a:p>
-                  </a:txBody>
-                  <a:tcPr marL="67990" marR="67990" marT="33995" marB="33995" anchor="ctr"/>
-                </a:tc>
-                <a:extLst>
-                  <a:ext uri="{0D108BD9-81ED-4DB2-BD59-A6C34878D82A}">
-                    <a16:rowId xmlns:a16="http://schemas.microsoft.com/office/drawing/2014/main" val="1033963505"/>
-                  </a:ext>
-                </a:extLst>
-              </a:tr>
-              <a:tr h="271959">
-                <a:tc>
-                  <a:txBody>
-                    <a:bodyPr/>
-                    <a:lstStyle/>
-                    <a:p>
-                      <a:pPr fontAlgn="base"/>
-                      <a:r>
-                        <a:rPr lang="en-US" sz="1300">
-                          <a:effectLst/>
-                        </a:rPr>
-                        <a:t>9</a:t>
-                      </a:r>
-                    </a:p>
-                  </a:txBody>
-                  <a:tcPr marL="67990" marR="67990" marT="33995" marB="33995" anchor="ctr"/>
-                </a:tc>
-                <a:tc>
-                  <a:txBody>
-                    <a:bodyPr/>
-                    <a:lstStyle/>
-                    <a:p>
-                      <a:pPr fontAlgn="base"/>
-                      <a:r>
-                        <a:rPr lang="en-US" sz="1300">
-                          <a:effectLst/>
-                        </a:rPr>
-                        <a:t>B</a:t>
-                      </a:r>
-                    </a:p>
-                  </a:txBody>
-                  <a:tcPr marL="67990" marR="67990" marT="33995" marB="33995" anchor="ctr"/>
-                </a:tc>
-                <a:tc>
-                  <a:txBody>
-                    <a:bodyPr/>
-                    <a:lstStyle/>
-                    <a:p>
-                      <a:pPr fontAlgn="base"/>
-                      <a:r>
-                        <a:rPr lang="en-US" sz="1300">
-                          <a:effectLst/>
-                        </a:rPr>
-                        <a:t>82</a:t>
-                      </a:r>
-                    </a:p>
-                  </a:txBody>
-                  <a:tcPr marL="67990" marR="67990" marT="33995" marB="33995" anchor="ctr"/>
-                </a:tc>
-                <a:extLst>
-                  <a:ext uri="{0D108BD9-81ED-4DB2-BD59-A6C34878D82A}">
-                    <a16:rowId xmlns:a16="http://schemas.microsoft.com/office/drawing/2014/main" val="1064304118"/>
-                  </a:ext>
-                </a:extLst>
-              </a:tr>
-              <a:tr h="271959">
-                <a:tc>
-                  <a:txBody>
-                    <a:bodyPr/>
-                    <a:lstStyle/>
-                    <a:p>
-                      <a:pPr fontAlgn="base"/>
-                      <a:r>
-                        <a:rPr lang="en-US" sz="1300">
-                          <a:effectLst/>
-                        </a:rPr>
-                        <a:t>10</a:t>
-                      </a:r>
-                    </a:p>
-                  </a:txBody>
-                  <a:tcPr marL="67990" marR="67990" marT="33995" marB="33995" anchor="ctr"/>
-                </a:tc>
-                <a:tc>
-                  <a:txBody>
-                    <a:bodyPr/>
-                    <a:lstStyle/>
-                    <a:p>
-                      <a:pPr fontAlgn="base"/>
-                      <a:r>
-                        <a:rPr lang="en-US" sz="1300">
-                          <a:effectLst/>
-                        </a:rPr>
-                        <a:t>B</a:t>
-                      </a:r>
-                    </a:p>
-                  </a:txBody>
-                  <a:tcPr marL="67990" marR="67990" marT="33995" marB="33995" anchor="ctr"/>
-                </a:tc>
-                <a:tc>
-                  <a:txBody>
-                    <a:bodyPr/>
-                    <a:lstStyle/>
-                    <a:p>
-                      <a:pPr fontAlgn="base"/>
-                      <a:r>
-                        <a:rPr lang="en-US" sz="1300">
-                          <a:effectLst/>
-                        </a:rPr>
-                        <a:t>77</a:t>
-                      </a:r>
-                    </a:p>
-                  </a:txBody>
-                  <a:tcPr marL="67990" marR="67990" marT="33995" marB="33995" anchor="ctr"/>
-                </a:tc>
-                <a:extLst>
-                  <a:ext uri="{0D108BD9-81ED-4DB2-BD59-A6C34878D82A}">
-                    <a16:rowId xmlns:a16="http://schemas.microsoft.com/office/drawing/2014/main" val="343819895"/>
-                  </a:ext>
-                </a:extLst>
-              </a:tr>
-              <a:tr h="271959">
-                <a:tc>
-                  <a:txBody>
-                    <a:bodyPr/>
-                    <a:lstStyle/>
-                    <a:p>
-                      <a:pPr fontAlgn="base"/>
-                      <a:r>
-                        <a:rPr lang="en-US" sz="1300">
-                          <a:effectLst/>
-                        </a:rPr>
-                        <a:t>11</a:t>
-                      </a:r>
-                    </a:p>
-                  </a:txBody>
-                  <a:tcPr marL="67990" marR="67990" marT="33995" marB="33995" anchor="ctr"/>
-                </a:tc>
-                <a:tc>
-                  <a:txBody>
-                    <a:bodyPr/>
-                    <a:lstStyle/>
-                    <a:p>
-                      <a:pPr fontAlgn="base"/>
-                      <a:r>
-                        <a:rPr lang="en-US" sz="1300">
-                          <a:effectLst/>
-                        </a:rPr>
-                        <a:t>C</a:t>
-                      </a:r>
-                    </a:p>
-                  </a:txBody>
-                  <a:tcPr marL="67990" marR="67990" marT="33995" marB="33995" anchor="ctr"/>
-                </a:tc>
-                <a:tc>
-                  <a:txBody>
-                    <a:bodyPr/>
-                    <a:lstStyle/>
-                    <a:p>
-                      <a:pPr fontAlgn="base"/>
-                      <a:r>
-                        <a:rPr lang="en-US" sz="1300">
-                          <a:effectLst/>
-                        </a:rPr>
-                        <a:t>90</a:t>
-                      </a:r>
-                    </a:p>
-                  </a:txBody>
-                  <a:tcPr marL="67990" marR="67990" marT="33995" marB="33995" anchor="ctr"/>
-                </a:tc>
-                <a:extLst>
-                  <a:ext uri="{0D108BD9-81ED-4DB2-BD59-A6C34878D82A}">
-                    <a16:rowId xmlns:a16="http://schemas.microsoft.com/office/drawing/2014/main" val="2960786143"/>
-                  </a:ext>
-                </a:extLst>
-              </a:tr>
-              <a:tr h="271959">
-                <a:tc>
-                  <a:txBody>
-                    <a:bodyPr/>
-                    <a:lstStyle/>
-                    <a:p>
-                      <a:pPr fontAlgn="base"/>
-                      <a:r>
-                        <a:rPr lang="en-US" sz="1300">
-                          <a:effectLst/>
-                        </a:rPr>
-                        <a:t>12</a:t>
-                      </a:r>
-                    </a:p>
-                  </a:txBody>
-                  <a:tcPr marL="67990" marR="67990" marT="33995" marB="33995" anchor="ctr"/>
-                </a:tc>
-                <a:tc>
-                  <a:txBody>
-                    <a:bodyPr/>
-                    <a:lstStyle/>
-                    <a:p>
-                      <a:pPr fontAlgn="base"/>
-                      <a:r>
-                        <a:rPr lang="en-US" sz="1300">
-                          <a:effectLst/>
-                        </a:rPr>
-                        <a:t>C</a:t>
-                      </a:r>
-                    </a:p>
-                  </a:txBody>
-                  <a:tcPr marL="67990" marR="67990" marT="33995" marB="33995" anchor="ctr"/>
-                </a:tc>
-                <a:tc>
-                  <a:txBody>
-                    <a:bodyPr/>
-                    <a:lstStyle/>
-                    <a:p>
-                      <a:pPr fontAlgn="base"/>
-                      <a:r>
-                        <a:rPr lang="en-US" sz="1300">
-                          <a:effectLst/>
-                        </a:rPr>
-                        <a:t>92</a:t>
-                      </a:r>
-                    </a:p>
-                  </a:txBody>
-                  <a:tcPr marL="67990" marR="67990" marT="33995" marB="33995" anchor="ctr"/>
-                </a:tc>
-                <a:extLst>
-                  <a:ext uri="{0D108BD9-81ED-4DB2-BD59-A6C34878D82A}">
-                    <a16:rowId xmlns:a16="http://schemas.microsoft.com/office/drawing/2014/main" val="2250534586"/>
-                  </a:ext>
-                </a:extLst>
-              </a:tr>
-              <a:tr h="271959">
-                <a:tc>
-                  <a:txBody>
-                    <a:bodyPr/>
-                    <a:lstStyle/>
-                    <a:p>
-                      <a:pPr fontAlgn="base"/>
-                      <a:r>
-                        <a:rPr lang="en-US" sz="1300">
-                          <a:effectLst/>
-                        </a:rPr>
-                        <a:t>13</a:t>
-                      </a:r>
-                    </a:p>
-                  </a:txBody>
-                  <a:tcPr marL="67990" marR="67990" marT="33995" marB="33995" anchor="ctr"/>
-                </a:tc>
-                <a:tc>
-                  <a:txBody>
-                    <a:bodyPr/>
-                    <a:lstStyle/>
-                    <a:p>
-                      <a:pPr fontAlgn="base"/>
-                      <a:r>
-                        <a:rPr lang="en-US" sz="1300">
-                          <a:effectLst/>
-                        </a:rPr>
-                        <a:t>C</a:t>
-                      </a:r>
-                    </a:p>
-                  </a:txBody>
-                  <a:tcPr marL="67990" marR="67990" marT="33995" marB="33995" anchor="ctr"/>
-                </a:tc>
-                <a:tc>
-                  <a:txBody>
-                    <a:bodyPr/>
-                    <a:lstStyle/>
-                    <a:p>
-                      <a:pPr fontAlgn="base"/>
-                      <a:r>
-                        <a:rPr lang="en-US" sz="1300">
-                          <a:effectLst/>
-                        </a:rPr>
-                        <a:t>95</a:t>
-                      </a:r>
-                    </a:p>
-                  </a:txBody>
-                  <a:tcPr marL="67990" marR="67990" marT="33995" marB="33995" anchor="ctr"/>
-                </a:tc>
-                <a:extLst>
-                  <a:ext uri="{0D108BD9-81ED-4DB2-BD59-A6C34878D82A}">
-                    <a16:rowId xmlns:a16="http://schemas.microsoft.com/office/drawing/2014/main" val="2032676665"/>
-                  </a:ext>
-                </a:extLst>
-              </a:tr>
-              <a:tr h="271959">
-                <a:tc>
-                  <a:txBody>
-                    <a:bodyPr/>
-                    <a:lstStyle/>
-                    <a:p>
-                      <a:pPr fontAlgn="base"/>
-                      <a:r>
-                        <a:rPr lang="en-US" sz="1300">
-                          <a:effectLst/>
-                        </a:rPr>
-                        <a:t>14</a:t>
-                      </a:r>
-                    </a:p>
-                  </a:txBody>
-                  <a:tcPr marL="67990" marR="67990" marT="33995" marB="33995" anchor="ctr"/>
-                </a:tc>
-                <a:tc>
-                  <a:txBody>
-                    <a:bodyPr/>
-                    <a:lstStyle/>
-                    <a:p>
-                      <a:pPr fontAlgn="base"/>
-                      <a:r>
-                        <a:rPr lang="en-US" sz="1300">
-                          <a:effectLst/>
-                        </a:rPr>
-                        <a:t>C</a:t>
-                      </a:r>
-                    </a:p>
-                  </a:txBody>
-                  <a:tcPr marL="67990" marR="67990" marT="33995" marB="33995" anchor="ctr"/>
-                </a:tc>
-                <a:tc>
-                  <a:txBody>
-                    <a:bodyPr/>
-                    <a:lstStyle/>
-                    <a:p>
-                      <a:pPr fontAlgn="base"/>
-                      <a:r>
-                        <a:rPr lang="en-US" sz="1300">
-                          <a:effectLst/>
-                        </a:rPr>
-                        <a:t>91</a:t>
-                      </a:r>
-                    </a:p>
-                  </a:txBody>
-                  <a:tcPr marL="67990" marR="67990" marT="33995" marB="33995" anchor="ctr"/>
-                </a:tc>
-                <a:extLst>
-                  <a:ext uri="{0D108BD9-81ED-4DB2-BD59-A6C34878D82A}">
-                    <a16:rowId xmlns:a16="http://schemas.microsoft.com/office/drawing/2014/main" val="2361817565"/>
-                  </a:ext>
-                </a:extLst>
-              </a:tr>
-              <a:tr h="271959">
-                <a:tc>
-                  <a:txBody>
-                    <a:bodyPr/>
-                    <a:lstStyle/>
-                    <a:p>
-                      <a:pPr fontAlgn="base"/>
-                      <a:r>
-                        <a:rPr lang="en-US" sz="1300">
-                          <a:effectLst/>
-                        </a:rPr>
-                        <a:t>15</a:t>
-                      </a:r>
-                    </a:p>
-                  </a:txBody>
-                  <a:tcPr marL="67990" marR="67990" marT="33995" marB="33995" anchor="ctr"/>
-                </a:tc>
-                <a:tc>
-                  <a:txBody>
-                    <a:bodyPr/>
-                    <a:lstStyle/>
-                    <a:p>
-                      <a:pPr fontAlgn="base"/>
-                      <a:r>
-                        <a:rPr lang="en-US" sz="1300">
-                          <a:effectLst/>
-                        </a:rPr>
-                        <a:t>C</a:t>
-                      </a:r>
-                    </a:p>
-                  </a:txBody>
-                  <a:tcPr marL="67990" marR="67990" marT="33995" marB="33995" anchor="ctr"/>
-                </a:tc>
-                <a:tc>
-                  <a:txBody>
-                    <a:bodyPr/>
-                    <a:lstStyle/>
-                    <a:p>
-                      <a:pPr fontAlgn="base"/>
-                      <a:r>
-                        <a:rPr lang="en-US" sz="1300" dirty="0">
-                          <a:effectLst/>
-                        </a:rPr>
-                        <a:t>94</a:t>
-                      </a:r>
-                    </a:p>
-                  </a:txBody>
-                  <a:tcPr marL="67990" marR="67990" marT="33995" marB="33995" anchor="ctr"/>
-                </a:tc>
-                <a:extLst>
-                  <a:ext uri="{0D108BD9-81ED-4DB2-BD59-A6C34878D82A}">
-                    <a16:rowId xmlns:a16="http://schemas.microsoft.com/office/drawing/2014/main" val="1358184112"/>
-                  </a:ext>
-                </a:extLst>
-              </a:tr>
-            </a:tbl>
-          </a:graphicData>
-        </a:graphic>
-      </p:graphicFrame>
-    </p:spTree>
-    <p:extLst>
-      <p:ext uri="{BB962C8B-B14F-4D97-AF65-F5344CB8AC3E}">
-        <p14:creationId xmlns:p14="http://schemas.microsoft.com/office/powerpoint/2010/main" val="2170303756"/>
       </p:ext>
     </p:extLst>
   </p:cSld>
@@ -37383,6 +36257,1075 @@
 </file>
 
 <file path=ppt/slides/slide50.xml><?xml version="1.0" encoding="utf-8"?>
+<p:sld xmlns:a="http://schemas.openxmlformats.org/drawingml/2006/main" xmlns:r="http://schemas.openxmlformats.org/officeDocument/2006/relationships" xmlns:p="http://schemas.openxmlformats.org/presentationml/2006/main">
+  <p:cSld>
+    <p:spTree>
+      <p:nvGrpSpPr>
+        <p:cNvPr id="1" name=""/>
+        <p:cNvGrpSpPr/>
+        <p:nvPr/>
+      </p:nvGrpSpPr>
+      <p:grpSpPr>
+        <a:xfrm>
+          <a:off x="0" y="0"/>
+          <a:ext cx="0" cy="0"/>
+          <a:chOff x="0" y="0"/>
+          <a:chExt cx="0" cy="0"/>
+        </a:xfrm>
+      </p:grpSpPr>
+      <p:sp>
+        <p:nvSpPr>
+          <p:cNvPr id="2" name="Title 1">
+            <a:extLst>
+              <a:ext uri="{FF2B5EF4-FFF2-40B4-BE49-F238E27FC236}">
+                <a16:creationId xmlns:a16="http://schemas.microsoft.com/office/drawing/2014/main" id="{B27049DC-2646-5AA2-FEFD-C08185FCAF02}"/>
+              </a:ext>
+            </a:extLst>
+          </p:cNvPr>
+          <p:cNvSpPr>
+            <a:spLocks noGrp="1"/>
+          </p:cNvSpPr>
+          <p:nvPr>
+            <p:ph type="title"/>
+          </p:nvPr>
+        </p:nvSpPr>
+        <p:spPr/>
+        <p:txBody>
+          <a:bodyPr/>
+          <a:lstStyle/>
+          <a:p>
+            <a:r>
+              <a:rPr lang="en-US" dirty="0"/>
+              <a:t>ANOVA Example</a:t>
+            </a:r>
+          </a:p>
+        </p:txBody>
+      </p:sp>
+      <p:sp>
+        <p:nvSpPr>
+          <p:cNvPr id="3" name="Content Placeholder 2">
+            <a:extLst>
+              <a:ext uri="{FF2B5EF4-FFF2-40B4-BE49-F238E27FC236}">
+                <a16:creationId xmlns:a16="http://schemas.microsoft.com/office/drawing/2014/main" id="{4D106FBB-198D-A7E8-03C4-7101324CD9F3}"/>
+              </a:ext>
+            </a:extLst>
+          </p:cNvPr>
+          <p:cNvSpPr>
+            <a:spLocks noGrp="1"/>
+          </p:cNvSpPr>
+          <p:nvPr>
+            <p:ph idx="1"/>
+          </p:nvPr>
+        </p:nvSpPr>
+        <p:spPr>
+          <a:xfrm>
+            <a:off x="838199" y="1706007"/>
+            <a:ext cx="7631349" cy="4991039"/>
+          </a:xfrm>
+        </p:spPr>
+        <p:txBody>
+          <a:bodyPr>
+            <a:normAutofit/>
+          </a:bodyPr>
+          <a:lstStyle/>
+          <a:p>
+            <a:r>
+              <a:rPr lang="en-US" sz="2000" dirty="0"/>
+              <a:t>Scenario: A school tests three different teaching methods to determine which one results in the best performance on a standardized test. </a:t>
+            </a:r>
+          </a:p>
+          <a:p>
+            <a:r>
+              <a:rPr lang="en-US" sz="2000" dirty="0"/>
+              <a:t>The students are randomly assigned to one of three groups, each receiving instruction through a different method. </a:t>
+            </a:r>
+          </a:p>
+          <a:p>
+            <a:r>
+              <a:rPr lang="en-US" sz="2000" dirty="0"/>
+              <a:t>Their scores on a standardized test are recorded.</a:t>
+            </a:r>
+          </a:p>
+          <a:p>
+            <a:r>
+              <a:rPr lang="en-US" sz="2000" dirty="0"/>
+              <a:t>Variables:</a:t>
+            </a:r>
+          </a:p>
+          <a:p>
+            <a:pPr lvl="1"/>
+            <a:r>
+              <a:rPr lang="en-US" sz="1800" dirty="0"/>
+              <a:t>Group: The teaching method group (A, B, C)</a:t>
+            </a:r>
+          </a:p>
+          <a:p>
+            <a:pPr lvl="1"/>
+            <a:r>
+              <a:rPr lang="en-US" sz="1800" dirty="0"/>
+              <a:t>Score: The score each student received on the standardized test.</a:t>
+            </a:r>
+          </a:p>
+          <a:p>
+            <a:pPr lvl="1"/>
+            <a:endParaRPr lang="en-US" sz="1800" dirty="0"/>
+          </a:p>
+        </p:txBody>
+      </p:sp>
+      <p:graphicFrame>
+        <p:nvGraphicFramePr>
+          <p:cNvPr id="4" name="Table 3">
+            <a:extLst>
+              <a:ext uri="{FF2B5EF4-FFF2-40B4-BE49-F238E27FC236}">
+                <a16:creationId xmlns:a16="http://schemas.microsoft.com/office/drawing/2014/main" id="{23CF52D0-9903-D0FC-10CC-382F02269359}"/>
+              </a:ext>
+            </a:extLst>
+          </p:cNvPr>
+          <p:cNvGraphicFramePr>
+            <a:graphicFrameLocks noGrp="1"/>
+          </p:cNvGraphicFramePr>
+          <p:nvPr>
+            <p:extLst>
+              <p:ext uri="{D42A27DB-BD31-4B8C-83A1-F6EECF244321}">
+                <p14:modId xmlns:p14="http://schemas.microsoft.com/office/powerpoint/2010/main" val="2765110422"/>
+              </p:ext>
+            </p:extLst>
+          </p:nvPr>
+        </p:nvGraphicFramePr>
+        <p:xfrm>
+          <a:off x="9038422" y="1706007"/>
+          <a:ext cx="2224587" cy="4543615"/>
+        </p:xfrm>
+        <a:graphic>
+          <a:graphicData uri="http://schemas.openxmlformats.org/drawingml/2006/table">
+            <a:tbl>
+              <a:tblPr>
+                <a:tableStyleId>{9D7B26C5-4107-4FEC-AEDC-1716B250A1EF}</a:tableStyleId>
+              </a:tblPr>
+              <a:tblGrid>
+                <a:gridCol w="741529">
+                  <a:extLst>
+                    <a:ext uri="{9D8B030D-6E8A-4147-A177-3AD203B41FA5}">
+                      <a16:colId xmlns:a16="http://schemas.microsoft.com/office/drawing/2014/main" val="4040225334"/>
+                    </a:ext>
+                  </a:extLst>
+                </a:gridCol>
+                <a:gridCol w="741529">
+                  <a:extLst>
+                    <a:ext uri="{9D8B030D-6E8A-4147-A177-3AD203B41FA5}">
+                      <a16:colId xmlns:a16="http://schemas.microsoft.com/office/drawing/2014/main" val="2431098428"/>
+                    </a:ext>
+                  </a:extLst>
+                </a:gridCol>
+                <a:gridCol w="741529">
+                  <a:extLst>
+                    <a:ext uri="{9D8B030D-6E8A-4147-A177-3AD203B41FA5}">
+                      <a16:colId xmlns:a16="http://schemas.microsoft.com/office/drawing/2014/main" val="1990735719"/>
+                    </a:ext>
+                  </a:extLst>
+                </a:gridCol>
+              </a:tblGrid>
+              <a:tr h="271959">
+                <a:tc>
+                  <a:txBody>
+                    <a:bodyPr/>
+                    <a:lstStyle/>
+                    <a:p>
+                      <a:pPr fontAlgn="b"/>
+                      <a:r>
+                        <a:rPr lang="en-US" sz="1300" b="1">
+                          <a:effectLst/>
+                        </a:rPr>
+                        <a:t>Student ID</a:t>
+                      </a:r>
+                    </a:p>
+                  </a:txBody>
+                  <a:tcPr marL="67990" marR="67990" marT="33995" marB="33995" anchor="b"/>
+                </a:tc>
+                <a:tc>
+                  <a:txBody>
+                    <a:bodyPr/>
+                    <a:lstStyle/>
+                    <a:p>
+                      <a:pPr fontAlgn="b"/>
+                      <a:r>
+                        <a:rPr lang="en-US" sz="1300" b="1">
+                          <a:effectLst/>
+                        </a:rPr>
+                        <a:t>Group</a:t>
+                      </a:r>
+                    </a:p>
+                  </a:txBody>
+                  <a:tcPr marL="67990" marR="67990" marT="33995" marB="33995" anchor="b"/>
+                </a:tc>
+                <a:tc>
+                  <a:txBody>
+                    <a:bodyPr/>
+                    <a:lstStyle/>
+                    <a:p>
+                      <a:pPr fontAlgn="b"/>
+                      <a:r>
+                        <a:rPr lang="en-US" sz="1300" b="1">
+                          <a:effectLst/>
+                        </a:rPr>
+                        <a:t>Score</a:t>
+                      </a:r>
+                    </a:p>
+                  </a:txBody>
+                  <a:tcPr marL="67990" marR="67990" marT="33995" marB="33995" anchor="b"/>
+                </a:tc>
+                <a:extLst>
+                  <a:ext uri="{0D108BD9-81ED-4DB2-BD59-A6C34878D82A}">
+                    <a16:rowId xmlns:a16="http://schemas.microsoft.com/office/drawing/2014/main" val="2519526074"/>
+                  </a:ext>
+                </a:extLst>
+              </a:tr>
+              <a:tr h="271959">
+                <a:tc>
+                  <a:txBody>
+                    <a:bodyPr/>
+                    <a:lstStyle/>
+                    <a:p>
+                      <a:pPr fontAlgn="base"/>
+                      <a:r>
+                        <a:rPr lang="en-US" sz="1300">
+                          <a:effectLst/>
+                        </a:rPr>
+                        <a:t>1</a:t>
+                      </a:r>
+                    </a:p>
+                  </a:txBody>
+                  <a:tcPr marL="67990" marR="67990" marT="33995" marB="33995" anchor="ctr"/>
+                </a:tc>
+                <a:tc>
+                  <a:txBody>
+                    <a:bodyPr/>
+                    <a:lstStyle/>
+                    <a:p>
+                      <a:pPr fontAlgn="base"/>
+                      <a:r>
+                        <a:rPr lang="en-US" sz="1300">
+                          <a:effectLst/>
+                        </a:rPr>
+                        <a:t>A</a:t>
+                      </a:r>
+                    </a:p>
+                  </a:txBody>
+                  <a:tcPr marL="67990" marR="67990" marT="33995" marB="33995" anchor="ctr"/>
+                </a:tc>
+                <a:tc>
+                  <a:txBody>
+                    <a:bodyPr/>
+                    <a:lstStyle/>
+                    <a:p>
+                      <a:pPr fontAlgn="base"/>
+                      <a:r>
+                        <a:rPr lang="en-US" sz="1300">
+                          <a:effectLst/>
+                        </a:rPr>
+                        <a:t>82</a:t>
+                      </a:r>
+                    </a:p>
+                  </a:txBody>
+                  <a:tcPr marL="67990" marR="67990" marT="33995" marB="33995" anchor="ctr"/>
+                </a:tc>
+                <a:extLst>
+                  <a:ext uri="{0D108BD9-81ED-4DB2-BD59-A6C34878D82A}">
+                    <a16:rowId xmlns:a16="http://schemas.microsoft.com/office/drawing/2014/main" val="2379991012"/>
+                  </a:ext>
+                </a:extLst>
+              </a:tr>
+              <a:tr h="271959">
+                <a:tc>
+                  <a:txBody>
+                    <a:bodyPr/>
+                    <a:lstStyle/>
+                    <a:p>
+                      <a:pPr fontAlgn="base"/>
+                      <a:r>
+                        <a:rPr lang="en-US" sz="1300">
+                          <a:effectLst/>
+                        </a:rPr>
+                        <a:t>2</a:t>
+                      </a:r>
+                    </a:p>
+                  </a:txBody>
+                  <a:tcPr marL="67990" marR="67990" marT="33995" marB="33995" anchor="ctr"/>
+                </a:tc>
+                <a:tc>
+                  <a:txBody>
+                    <a:bodyPr/>
+                    <a:lstStyle/>
+                    <a:p>
+                      <a:pPr fontAlgn="base"/>
+                      <a:r>
+                        <a:rPr lang="en-US" sz="1300">
+                          <a:effectLst/>
+                        </a:rPr>
+                        <a:t>A</a:t>
+                      </a:r>
+                    </a:p>
+                  </a:txBody>
+                  <a:tcPr marL="67990" marR="67990" marT="33995" marB="33995" anchor="ctr"/>
+                </a:tc>
+                <a:tc>
+                  <a:txBody>
+                    <a:bodyPr/>
+                    <a:lstStyle/>
+                    <a:p>
+                      <a:pPr fontAlgn="base"/>
+                      <a:r>
+                        <a:rPr lang="en-US" sz="1300">
+                          <a:effectLst/>
+                        </a:rPr>
+                        <a:t>88</a:t>
+                      </a:r>
+                    </a:p>
+                  </a:txBody>
+                  <a:tcPr marL="67990" marR="67990" marT="33995" marB="33995" anchor="ctr"/>
+                </a:tc>
+                <a:extLst>
+                  <a:ext uri="{0D108BD9-81ED-4DB2-BD59-A6C34878D82A}">
+                    <a16:rowId xmlns:a16="http://schemas.microsoft.com/office/drawing/2014/main" val="3645977183"/>
+                  </a:ext>
+                </a:extLst>
+              </a:tr>
+              <a:tr h="271959">
+                <a:tc>
+                  <a:txBody>
+                    <a:bodyPr/>
+                    <a:lstStyle/>
+                    <a:p>
+                      <a:pPr fontAlgn="base"/>
+                      <a:r>
+                        <a:rPr lang="en-US" sz="1300">
+                          <a:effectLst/>
+                        </a:rPr>
+                        <a:t>3</a:t>
+                      </a:r>
+                    </a:p>
+                  </a:txBody>
+                  <a:tcPr marL="67990" marR="67990" marT="33995" marB="33995" anchor="ctr"/>
+                </a:tc>
+                <a:tc>
+                  <a:txBody>
+                    <a:bodyPr/>
+                    <a:lstStyle/>
+                    <a:p>
+                      <a:pPr fontAlgn="base"/>
+                      <a:r>
+                        <a:rPr lang="en-US" sz="1300">
+                          <a:effectLst/>
+                        </a:rPr>
+                        <a:t>A</a:t>
+                      </a:r>
+                    </a:p>
+                  </a:txBody>
+                  <a:tcPr marL="67990" marR="67990" marT="33995" marB="33995" anchor="ctr"/>
+                </a:tc>
+                <a:tc>
+                  <a:txBody>
+                    <a:bodyPr/>
+                    <a:lstStyle/>
+                    <a:p>
+                      <a:pPr fontAlgn="base"/>
+                      <a:r>
+                        <a:rPr lang="en-US" sz="1300">
+                          <a:effectLst/>
+                        </a:rPr>
+                        <a:t>84</a:t>
+                      </a:r>
+                    </a:p>
+                  </a:txBody>
+                  <a:tcPr marL="67990" marR="67990" marT="33995" marB="33995" anchor="ctr"/>
+                </a:tc>
+                <a:extLst>
+                  <a:ext uri="{0D108BD9-81ED-4DB2-BD59-A6C34878D82A}">
+                    <a16:rowId xmlns:a16="http://schemas.microsoft.com/office/drawing/2014/main" val="2127075430"/>
+                  </a:ext>
+                </a:extLst>
+              </a:tr>
+              <a:tr h="271959">
+                <a:tc>
+                  <a:txBody>
+                    <a:bodyPr/>
+                    <a:lstStyle/>
+                    <a:p>
+                      <a:pPr fontAlgn="base"/>
+                      <a:r>
+                        <a:rPr lang="en-US" sz="1300">
+                          <a:effectLst/>
+                        </a:rPr>
+                        <a:t>4</a:t>
+                      </a:r>
+                    </a:p>
+                  </a:txBody>
+                  <a:tcPr marL="67990" marR="67990" marT="33995" marB="33995" anchor="ctr"/>
+                </a:tc>
+                <a:tc>
+                  <a:txBody>
+                    <a:bodyPr/>
+                    <a:lstStyle/>
+                    <a:p>
+                      <a:pPr fontAlgn="base"/>
+                      <a:r>
+                        <a:rPr lang="en-US" sz="1300">
+                          <a:effectLst/>
+                        </a:rPr>
+                        <a:t>A</a:t>
+                      </a:r>
+                    </a:p>
+                  </a:txBody>
+                  <a:tcPr marL="67990" marR="67990" marT="33995" marB="33995" anchor="ctr"/>
+                </a:tc>
+                <a:tc>
+                  <a:txBody>
+                    <a:bodyPr/>
+                    <a:lstStyle/>
+                    <a:p>
+                      <a:pPr fontAlgn="base"/>
+                      <a:r>
+                        <a:rPr lang="en-US" sz="1300">
+                          <a:effectLst/>
+                        </a:rPr>
+                        <a:t>90</a:t>
+                      </a:r>
+                    </a:p>
+                  </a:txBody>
+                  <a:tcPr marL="67990" marR="67990" marT="33995" marB="33995" anchor="ctr"/>
+                </a:tc>
+                <a:extLst>
+                  <a:ext uri="{0D108BD9-81ED-4DB2-BD59-A6C34878D82A}">
+                    <a16:rowId xmlns:a16="http://schemas.microsoft.com/office/drawing/2014/main" val="608421500"/>
+                  </a:ext>
+                </a:extLst>
+              </a:tr>
+              <a:tr h="271959">
+                <a:tc>
+                  <a:txBody>
+                    <a:bodyPr/>
+                    <a:lstStyle/>
+                    <a:p>
+                      <a:pPr fontAlgn="base"/>
+                      <a:r>
+                        <a:rPr lang="en-US" sz="1300">
+                          <a:effectLst/>
+                        </a:rPr>
+                        <a:t>5</a:t>
+                      </a:r>
+                    </a:p>
+                  </a:txBody>
+                  <a:tcPr marL="67990" marR="67990" marT="33995" marB="33995" anchor="ctr"/>
+                </a:tc>
+                <a:tc>
+                  <a:txBody>
+                    <a:bodyPr/>
+                    <a:lstStyle/>
+                    <a:p>
+                      <a:pPr fontAlgn="base"/>
+                      <a:r>
+                        <a:rPr lang="en-US" sz="1300">
+                          <a:effectLst/>
+                        </a:rPr>
+                        <a:t>A</a:t>
+                      </a:r>
+                    </a:p>
+                  </a:txBody>
+                  <a:tcPr marL="67990" marR="67990" marT="33995" marB="33995" anchor="ctr"/>
+                </a:tc>
+                <a:tc>
+                  <a:txBody>
+                    <a:bodyPr/>
+                    <a:lstStyle/>
+                    <a:p>
+                      <a:pPr fontAlgn="base"/>
+                      <a:r>
+                        <a:rPr lang="en-US" sz="1300">
+                          <a:effectLst/>
+                        </a:rPr>
+                        <a:t>85</a:t>
+                      </a:r>
+                    </a:p>
+                  </a:txBody>
+                  <a:tcPr marL="67990" marR="67990" marT="33995" marB="33995" anchor="ctr"/>
+                </a:tc>
+                <a:extLst>
+                  <a:ext uri="{0D108BD9-81ED-4DB2-BD59-A6C34878D82A}">
+                    <a16:rowId xmlns:a16="http://schemas.microsoft.com/office/drawing/2014/main" val="4028156413"/>
+                  </a:ext>
+                </a:extLst>
+              </a:tr>
+              <a:tr h="271959">
+                <a:tc>
+                  <a:txBody>
+                    <a:bodyPr/>
+                    <a:lstStyle/>
+                    <a:p>
+                      <a:pPr fontAlgn="base"/>
+                      <a:r>
+                        <a:rPr lang="en-US" sz="1300">
+                          <a:effectLst/>
+                        </a:rPr>
+                        <a:t>6</a:t>
+                      </a:r>
+                    </a:p>
+                  </a:txBody>
+                  <a:tcPr marL="67990" marR="67990" marT="33995" marB="33995" anchor="ctr"/>
+                </a:tc>
+                <a:tc>
+                  <a:txBody>
+                    <a:bodyPr/>
+                    <a:lstStyle/>
+                    <a:p>
+                      <a:pPr fontAlgn="base"/>
+                      <a:r>
+                        <a:rPr lang="en-US" sz="1300">
+                          <a:effectLst/>
+                        </a:rPr>
+                        <a:t>B</a:t>
+                      </a:r>
+                    </a:p>
+                  </a:txBody>
+                  <a:tcPr marL="67990" marR="67990" marT="33995" marB="33995" anchor="ctr"/>
+                </a:tc>
+                <a:tc>
+                  <a:txBody>
+                    <a:bodyPr/>
+                    <a:lstStyle/>
+                    <a:p>
+                      <a:pPr fontAlgn="base"/>
+                      <a:r>
+                        <a:rPr lang="en-US" sz="1300" dirty="0">
+                          <a:effectLst/>
+                        </a:rPr>
+                        <a:t>78</a:t>
+                      </a:r>
+                    </a:p>
+                  </a:txBody>
+                  <a:tcPr marL="67990" marR="67990" marT="33995" marB="33995" anchor="ctr"/>
+                </a:tc>
+                <a:extLst>
+                  <a:ext uri="{0D108BD9-81ED-4DB2-BD59-A6C34878D82A}">
+                    <a16:rowId xmlns:a16="http://schemas.microsoft.com/office/drawing/2014/main" val="1234083821"/>
+                  </a:ext>
+                </a:extLst>
+              </a:tr>
+              <a:tr h="271959">
+                <a:tc>
+                  <a:txBody>
+                    <a:bodyPr/>
+                    <a:lstStyle/>
+                    <a:p>
+                      <a:pPr fontAlgn="base"/>
+                      <a:r>
+                        <a:rPr lang="en-US" sz="1300" dirty="0">
+                          <a:effectLst/>
+                        </a:rPr>
+                        <a:t>7</a:t>
+                      </a:r>
+                    </a:p>
+                  </a:txBody>
+                  <a:tcPr marL="67990" marR="67990" marT="33995" marB="33995" anchor="ctr"/>
+                </a:tc>
+                <a:tc>
+                  <a:txBody>
+                    <a:bodyPr/>
+                    <a:lstStyle/>
+                    <a:p>
+                      <a:pPr fontAlgn="base"/>
+                      <a:r>
+                        <a:rPr lang="en-US" sz="1300">
+                          <a:effectLst/>
+                        </a:rPr>
+                        <a:t>B</a:t>
+                      </a:r>
+                    </a:p>
+                  </a:txBody>
+                  <a:tcPr marL="67990" marR="67990" marT="33995" marB="33995" anchor="ctr"/>
+                </a:tc>
+                <a:tc>
+                  <a:txBody>
+                    <a:bodyPr/>
+                    <a:lstStyle/>
+                    <a:p>
+                      <a:pPr fontAlgn="base"/>
+                      <a:r>
+                        <a:rPr lang="en-US" sz="1300">
+                          <a:effectLst/>
+                        </a:rPr>
+                        <a:t>75</a:t>
+                      </a:r>
+                    </a:p>
+                  </a:txBody>
+                  <a:tcPr marL="67990" marR="67990" marT="33995" marB="33995" anchor="ctr"/>
+                </a:tc>
+                <a:extLst>
+                  <a:ext uri="{0D108BD9-81ED-4DB2-BD59-A6C34878D82A}">
+                    <a16:rowId xmlns:a16="http://schemas.microsoft.com/office/drawing/2014/main" val="3431443898"/>
+                  </a:ext>
+                </a:extLst>
+              </a:tr>
+              <a:tr h="271959">
+                <a:tc>
+                  <a:txBody>
+                    <a:bodyPr/>
+                    <a:lstStyle/>
+                    <a:p>
+                      <a:pPr fontAlgn="base"/>
+                      <a:r>
+                        <a:rPr lang="en-US" sz="1300">
+                          <a:effectLst/>
+                        </a:rPr>
+                        <a:t>8</a:t>
+                      </a:r>
+                    </a:p>
+                  </a:txBody>
+                  <a:tcPr marL="67990" marR="67990" marT="33995" marB="33995" anchor="ctr"/>
+                </a:tc>
+                <a:tc>
+                  <a:txBody>
+                    <a:bodyPr/>
+                    <a:lstStyle/>
+                    <a:p>
+                      <a:pPr fontAlgn="base"/>
+                      <a:r>
+                        <a:rPr lang="en-US" sz="1300">
+                          <a:effectLst/>
+                        </a:rPr>
+                        <a:t>B</a:t>
+                      </a:r>
+                    </a:p>
+                  </a:txBody>
+                  <a:tcPr marL="67990" marR="67990" marT="33995" marB="33995" anchor="ctr"/>
+                </a:tc>
+                <a:tc>
+                  <a:txBody>
+                    <a:bodyPr/>
+                    <a:lstStyle/>
+                    <a:p>
+                      <a:pPr fontAlgn="base"/>
+                      <a:r>
+                        <a:rPr lang="en-US" sz="1300">
+                          <a:effectLst/>
+                        </a:rPr>
+                        <a:t>80</a:t>
+                      </a:r>
+                    </a:p>
+                  </a:txBody>
+                  <a:tcPr marL="67990" marR="67990" marT="33995" marB="33995" anchor="ctr"/>
+                </a:tc>
+                <a:extLst>
+                  <a:ext uri="{0D108BD9-81ED-4DB2-BD59-A6C34878D82A}">
+                    <a16:rowId xmlns:a16="http://schemas.microsoft.com/office/drawing/2014/main" val="1033963505"/>
+                  </a:ext>
+                </a:extLst>
+              </a:tr>
+              <a:tr h="271959">
+                <a:tc>
+                  <a:txBody>
+                    <a:bodyPr/>
+                    <a:lstStyle/>
+                    <a:p>
+                      <a:pPr fontAlgn="base"/>
+                      <a:r>
+                        <a:rPr lang="en-US" sz="1300">
+                          <a:effectLst/>
+                        </a:rPr>
+                        <a:t>9</a:t>
+                      </a:r>
+                    </a:p>
+                  </a:txBody>
+                  <a:tcPr marL="67990" marR="67990" marT="33995" marB="33995" anchor="ctr"/>
+                </a:tc>
+                <a:tc>
+                  <a:txBody>
+                    <a:bodyPr/>
+                    <a:lstStyle/>
+                    <a:p>
+                      <a:pPr fontAlgn="base"/>
+                      <a:r>
+                        <a:rPr lang="en-US" sz="1300">
+                          <a:effectLst/>
+                        </a:rPr>
+                        <a:t>B</a:t>
+                      </a:r>
+                    </a:p>
+                  </a:txBody>
+                  <a:tcPr marL="67990" marR="67990" marT="33995" marB="33995" anchor="ctr"/>
+                </a:tc>
+                <a:tc>
+                  <a:txBody>
+                    <a:bodyPr/>
+                    <a:lstStyle/>
+                    <a:p>
+                      <a:pPr fontAlgn="base"/>
+                      <a:r>
+                        <a:rPr lang="en-US" sz="1300">
+                          <a:effectLst/>
+                        </a:rPr>
+                        <a:t>82</a:t>
+                      </a:r>
+                    </a:p>
+                  </a:txBody>
+                  <a:tcPr marL="67990" marR="67990" marT="33995" marB="33995" anchor="ctr"/>
+                </a:tc>
+                <a:extLst>
+                  <a:ext uri="{0D108BD9-81ED-4DB2-BD59-A6C34878D82A}">
+                    <a16:rowId xmlns:a16="http://schemas.microsoft.com/office/drawing/2014/main" val="1064304118"/>
+                  </a:ext>
+                </a:extLst>
+              </a:tr>
+              <a:tr h="271959">
+                <a:tc>
+                  <a:txBody>
+                    <a:bodyPr/>
+                    <a:lstStyle/>
+                    <a:p>
+                      <a:pPr fontAlgn="base"/>
+                      <a:r>
+                        <a:rPr lang="en-US" sz="1300">
+                          <a:effectLst/>
+                        </a:rPr>
+                        <a:t>10</a:t>
+                      </a:r>
+                    </a:p>
+                  </a:txBody>
+                  <a:tcPr marL="67990" marR="67990" marT="33995" marB="33995" anchor="ctr"/>
+                </a:tc>
+                <a:tc>
+                  <a:txBody>
+                    <a:bodyPr/>
+                    <a:lstStyle/>
+                    <a:p>
+                      <a:pPr fontAlgn="base"/>
+                      <a:r>
+                        <a:rPr lang="en-US" sz="1300">
+                          <a:effectLst/>
+                        </a:rPr>
+                        <a:t>B</a:t>
+                      </a:r>
+                    </a:p>
+                  </a:txBody>
+                  <a:tcPr marL="67990" marR="67990" marT="33995" marB="33995" anchor="ctr"/>
+                </a:tc>
+                <a:tc>
+                  <a:txBody>
+                    <a:bodyPr/>
+                    <a:lstStyle/>
+                    <a:p>
+                      <a:pPr fontAlgn="base"/>
+                      <a:r>
+                        <a:rPr lang="en-US" sz="1300">
+                          <a:effectLst/>
+                        </a:rPr>
+                        <a:t>77</a:t>
+                      </a:r>
+                    </a:p>
+                  </a:txBody>
+                  <a:tcPr marL="67990" marR="67990" marT="33995" marB="33995" anchor="ctr"/>
+                </a:tc>
+                <a:extLst>
+                  <a:ext uri="{0D108BD9-81ED-4DB2-BD59-A6C34878D82A}">
+                    <a16:rowId xmlns:a16="http://schemas.microsoft.com/office/drawing/2014/main" val="343819895"/>
+                  </a:ext>
+                </a:extLst>
+              </a:tr>
+              <a:tr h="271959">
+                <a:tc>
+                  <a:txBody>
+                    <a:bodyPr/>
+                    <a:lstStyle/>
+                    <a:p>
+                      <a:pPr fontAlgn="base"/>
+                      <a:r>
+                        <a:rPr lang="en-US" sz="1300">
+                          <a:effectLst/>
+                        </a:rPr>
+                        <a:t>11</a:t>
+                      </a:r>
+                    </a:p>
+                  </a:txBody>
+                  <a:tcPr marL="67990" marR="67990" marT="33995" marB="33995" anchor="ctr"/>
+                </a:tc>
+                <a:tc>
+                  <a:txBody>
+                    <a:bodyPr/>
+                    <a:lstStyle/>
+                    <a:p>
+                      <a:pPr fontAlgn="base"/>
+                      <a:r>
+                        <a:rPr lang="en-US" sz="1300">
+                          <a:effectLst/>
+                        </a:rPr>
+                        <a:t>C</a:t>
+                      </a:r>
+                    </a:p>
+                  </a:txBody>
+                  <a:tcPr marL="67990" marR="67990" marT="33995" marB="33995" anchor="ctr"/>
+                </a:tc>
+                <a:tc>
+                  <a:txBody>
+                    <a:bodyPr/>
+                    <a:lstStyle/>
+                    <a:p>
+                      <a:pPr fontAlgn="base"/>
+                      <a:r>
+                        <a:rPr lang="en-US" sz="1300">
+                          <a:effectLst/>
+                        </a:rPr>
+                        <a:t>90</a:t>
+                      </a:r>
+                    </a:p>
+                  </a:txBody>
+                  <a:tcPr marL="67990" marR="67990" marT="33995" marB="33995" anchor="ctr"/>
+                </a:tc>
+                <a:extLst>
+                  <a:ext uri="{0D108BD9-81ED-4DB2-BD59-A6C34878D82A}">
+                    <a16:rowId xmlns:a16="http://schemas.microsoft.com/office/drawing/2014/main" val="2960786143"/>
+                  </a:ext>
+                </a:extLst>
+              </a:tr>
+              <a:tr h="271959">
+                <a:tc>
+                  <a:txBody>
+                    <a:bodyPr/>
+                    <a:lstStyle/>
+                    <a:p>
+                      <a:pPr fontAlgn="base"/>
+                      <a:r>
+                        <a:rPr lang="en-US" sz="1300">
+                          <a:effectLst/>
+                        </a:rPr>
+                        <a:t>12</a:t>
+                      </a:r>
+                    </a:p>
+                  </a:txBody>
+                  <a:tcPr marL="67990" marR="67990" marT="33995" marB="33995" anchor="ctr"/>
+                </a:tc>
+                <a:tc>
+                  <a:txBody>
+                    <a:bodyPr/>
+                    <a:lstStyle/>
+                    <a:p>
+                      <a:pPr fontAlgn="base"/>
+                      <a:r>
+                        <a:rPr lang="en-US" sz="1300">
+                          <a:effectLst/>
+                        </a:rPr>
+                        <a:t>C</a:t>
+                      </a:r>
+                    </a:p>
+                  </a:txBody>
+                  <a:tcPr marL="67990" marR="67990" marT="33995" marB="33995" anchor="ctr"/>
+                </a:tc>
+                <a:tc>
+                  <a:txBody>
+                    <a:bodyPr/>
+                    <a:lstStyle/>
+                    <a:p>
+                      <a:pPr fontAlgn="base"/>
+                      <a:r>
+                        <a:rPr lang="en-US" sz="1300">
+                          <a:effectLst/>
+                        </a:rPr>
+                        <a:t>92</a:t>
+                      </a:r>
+                    </a:p>
+                  </a:txBody>
+                  <a:tcPr marL="67990" marR="67990" marT="33995" marB="33995" anchor="ctr"/>
+                </a:tc>
+                <a:extLst>
+                  <a:ext uri="{0D108BD9-81ED-4DB2-BD59-A6C34878D82A}">
+                    <a16:rowId xmlns:a16="http://schemas.microsoft.com/office/drawing/2014/main" val="2250534586"/>
+                  </a:ext>
+                </a:extLst>
+              </a:tr>
+              <a:tr h="271959">
+                <a:tc>
+                  <a:txBody>
+                    <a:bodyPr/>
+                    <a:lstStyle/>
+                    <a:p>
+                      <a:pPr fontAlgn="base"/>
+                      <a:r>
+                        <a:rPr lang="en-US" sz="1300">
+                          <a:effectLst/>
+                        </a:rPr>
+                        <a:t>13</a:t>
+                      </a:r>
+                    </a:p>
+                  </a:txBody>
+                  <a:tcPr marL="67990" marR="67990" marT="33995" marB="33995" anchor="ctr"/>
+                </a:tc>
+                <a:tc>
+                  <a:txBody>
+                    <a:bodyPr/>
+                    <a:lstStyle/>
+                    <a:p>
+                      <a:pPr fontAlgn="base"/>
+                      <a:r>
+                        <a:rPr lang="en-US" sz="1300">
+                          <a:effectLst/>
+                        </a:rPr>
+                        <a:t>C</a:t>
+                      </a:r>
+                    </a:p>
+                  </a:txBody>
+                  <a:tcPr marL="67990" marR="67990" marT="33995" marB="33995" anchor="ctr"/>
+                </a:tc>
+                <a:tc>
+                  <a:txBody>
+                    <a:bodyPr/>
+                    <a:lstStyle/>
+                    <a:p>
+                      <a:pPr fontAlgn="base"/>
+                      <a:r>
+                        <a:rPr lang="en-US" sz="1300">
+                          <a:effectLst/>
+                        </a:rPr>
+                        <a:t>95</a:t>
+                      </a:r>
+                    </a:p>
+                  </a:txBody>
+                  <a:tcPr marL="67990" marR="67990" marT="33995" marB="33995" anchor="ctr"/>
+                </a:tc>
+                <a:extLst>
+                  <a:ext uri="{0D108BD9-81ED-4DB2-BD59-A6C34878D82A}">
+                    <a16:rowId xmlns:a16="http://schemas.microsoft.com/office/drawing/2014/main" val="2032676665"/>
+                  </a:ext>
+                </a:extLst>
+              </a:tr>
+              <a:tr h="271959">
+                <a:tc>
+                  <a:txBody>
+                    <a:bodyPr/>
+                    <a:lstStyle/>
+                    <a:p>
+                      <a:pPr fontAlgn="base"/>
+                      <a:r>
+                        <a:rPr lang="en-US" sz="1300">
+                          <a:effectLst/>
+                        </a:rPr>
+                        <a:t>14</a:t>
+                      </a:r>
+                    </a:p>
+                  </a:txBody>
+                  <a:tcPr marL="67990" marR="67990" marT="33995" marB="33995" anchor="ctr"/>
+                </a:tc>
+                <a:tc>
+                  <a:txBody>
+                    <a:bodyPr/>
+                    <a:lstStyle/>
+                    <a:p>
+                      <a:pPr fontAlgn="base"/>
+                      <a:r>
+                        <a:rPr lang="en-US" sz="1300">
+                          <a:effectLst/>
+                        </a:rPr>
+                        <a:t>C</a:t>
+                      </a:r>
+                    </a:p>
+                  </a:txBody>
+                  <a:tcPr marL="67990" marR="67990" marT="33995" marB="33995" anchor="ctr"/>
+                </a:tc>
+                <a:tc>
+                  <a:txBody>
+                    <a:bodyPr/>
+                    <a:lstStyle/>
+                    <a:p>
+                      <a:pPr fontAlgn="base"/>
+                      <a:r>
+                        <a:rPr lang="en-US" sz="1300">
+                          <a:effectLst/>
+                        </a:rPr>
+                        <a:t>91</a:t>
+                      </a:r>
+                    </a:p>
+                  </a:txBody>
+                  <a:tcPr marL="67990" marR="67990" marT="33995" marB="33995" anchor="ctr"/>
+                </a:tc>
+                <a:extLst>
+                  <a:ext uri="{0D108BD9-81ED-4DB2-BD59-A6C34878D82A}">
+                    <a16:rowId xmlns:a16="http://schemas.microsoft.com/office/drawing/2014/main" val="2361817565"/>
+                  </a:ext>
+                </a:extLst>
+              </a:tr>
+              <a:tr h="271959">
+                <a:tc>
+                  <a:txBody>
+                    <a:bodyPr/>
+                    <a:lstStyle/>
+                    <a:p>
+                      <a:pPr fontAlgn="base"/>
+                      <a:r>
+                        <a:rPr lang="en-US" sz="1300">
+                          <a:effectLst/>
+                        </a:rPr>
+                        <a:t>15</a:t>
+                      </a:r>
+                    </a:p>
+                  </a:txBody>
+                  <a:tcPr marL="67990" marR="67990" marT="33995" marB="33995" anchor="ctr"/>
+                </a:tc>
+                <a:tc>
+                  <a:txBody>
+                    <a:bodyPr/>
+                    <a:lstStyle/>
+                    <a:p>
+                      <a:pPr fontAlgn="base"/>
+                      <a:r>
+                        <a:rPr lang="en-US" sz="1300">
+                          <a:effectLst/>
+                        </a:rPr>
+                        <a:t>C</a:t>
+                      </a:r>
+                    </a:p>
+                  </a:txBody>
+                  <a:tcPr marL="67990" marR="67990" marT="33995" marB="33995" anchor="ctr"/>
+                </a:tc>
+                <a:tc>
+                  <a:txBody>
+                    <a:bodyPr/>
+                    <a:lstStyle/>
+                    <a:p>
+                      <a:pPr fontAlgn="base"/>
+                      <a:r>
+                        <a:rPr lang="en-US" sz="1300" dirty="0">
+                          <a:effectLst/>
+                        </a:rPr>
+                        <a:t>94</a:t>
+                      </a:r>
+                    </a:p>
+                  </a:txBody>
+                  <a:tcPr marL="67990" marR="67990" marT="33995" marB="33995" anchor="ctr"/>
+                </a:tc>
+                <a:extLst>
+                  <a:ext uri="{0D108BD9-81ED-4DB2-BD59-A6C34878D82A}">
+                    <a16:rowId xmlns:a16="http://schemas.microsoft.com/office/drawing/2014/main" val="1358184112"/>
+                  </a:ext>
+                </a:extLst>
+              </a:tr>
+            </a:tbl>
+          </a:graphicData>
+        </a:graphic>
+      </p:graphicFrame>
+    </p:spTree>
+    <p:extLst>
+      <p:ext uri="{BB962C8B-B14F-4D97-AF65-F5344CB8AC3E}">
+        <p14:creationId xmlns:p14="http://schemas.microsoft.com/office/powerpoint/2010/main" val="2170303756"/>
+      </p:ext>
+    </p:extLst>
+  </p:cSld>
+  <p:clrMapOvr>
+    <a:masterClrMapping/>
+  </p:clrMapOvr>
+  <p:transition spd="med">
+    <p:pull/>
+  </p:transition>
+</p:sld>
+</file>
+
+<file path=ppt/slides/slide51.xml><?xml version="1.0" encoding="utf-8"?>
 <p:sld xmlns:a="http://schemas.openxmlformats.org/drawingml/2006/main" xmlns:r="http://schemas.openxmlformats.org/officeDocument/2006/relationships" xmlns:p="http://schemas.openxmlformats.org/presentationml/2006/main">
   <p:cSld>
     <p:spTree>
@@ -37733,7 +37676,7 @@
 </p:sld>
 </file>
 
-<file path=ppt/slides/slide51.xml><?xml version="1.0" encoding="utf-8"?>
+<file path=ppt/slides/slide52.xml><?xml version="1.0" encoding="utf-8"?>
 <p:sld xmlns:a="http://schemas.openxmlformats.org/drawingml/2006/main" xmlns:r="http://schemas.openxmlformats.org/officeDocument/2006/relationships" xmlns:p="http://schemas.openxmlformats.org/presentationml/2006/main">
   <p:cSld>
     <p:spTree>
@@ -37922,7 +37865,7 @@
 </p:sld>
 </file>
 
-<file path=ppt/slides/slide52.xml><?xml version="1.0" encoding="utf-8"?>
+<file path=ppt/slides/slide53.xml><?xml version="1.0" encoding="utf-8"?>
 <p:sld xmlns:a="http://schemas.openxmlformats.org/drawingml/2006/main" xmlns:r="http://schemas.openxmlformats.org/officeDocument/2006/relationships" xmlns:p="http://schemas.openxmlformats.org/presentationml/2006/main">
   <p:cSld>
     <p:spTree>
@@ -38899,7 +38842,7 @@
 </p:sld>
 </file>
 
-<file path=ppt/slides/slide53.xml><?xml version="1.0" encoding="utf-8"?>
+<file path=ppt/slides/slide54.xml><?xml version="1.0" encoding="utf-8"?>
 <p:sld xmlns:a="http://schemas.openxmlformats.org/drawingml/2006/main" xmlns:r="http://schemas.openxmlformats.org/officeDocument/2006/relationships" xmlns:p="http://schemas.openxmlformats.org/presentationml/2006/main">
   <p:cSld>
     <p:spTree>

</xml_diff>